<commit_message>
Insert VLA发展趋势.png as new slide in Part 5 of PPT
</commit_message>
<xml_diff>
--- a/reports/VLA大模型技术分享报告.pptx
+++ b/reports/VLA大模型技术分享报告.pptx
@@ -29,6 +29,7 @@
     <p:sldId id="277" r:id="rId28"/>
     <p:sldId id="278" r:id="rId29"/>
     <p:sldId id="279" r:id="rId30"/>
+    <p:sldId id="282" r:id="rId33"/>
     <p:sldId id="280" r:id="rId31"/>
     <p:sldId id="281" r:id="rId32"/>
   </p:sldIdLst>
@@ -19044,7 +19045,7 @@
                 <a:latin typeface="Noto Sans CJK SC"/>
                 <a:ea typeface="Noto Sans CJK SC"/>
               </a:rPr>
-              <a:t>25</a:t>
+              <a:t>26</a:t>
             </a:r>
           </a:p>
         </p:txBody>
@@ -19271,6 +19272,405 @@
                 <a:ea typeface="Noto Sans CJK SC"/>
               </a:rPr>
               <a:t>VLA 大模型技术分享报告 · 具身智能技术组</a:t>
+            </a:r>
+          </a:p>
+        </p:txBody>
+      </p:sp>
+    </p:spTree>
+  </p:cSld>
+  <p:clrMapOvr>
+    <a:masterClrMapping/>
+  </p:clrMapOvr>
+</p:sld>
+</file>
+
+<file path=ppt/slides/slide27.xml><?xml version="1.0" encoding="utf-8"?>
+<p:sld xmlns:a="http://schemas.openxmlformats.org/drawingml/2006/main" xmlns:p="http://schemas.openxmlformats.org/presentationml/2006/main" xmlns:r="http://schemas.openxmlformats.org/officeDocument/2006/relationships">
+  <p:cSld>
+    <p:spTree>
+      <p:nvGrpSpPr>
+        <p:cNvPr id="1" name=""/>
+        <p:cNvGrpSpPr/>
+        <p:nvPr/>
+      </p:nvGrpSpPr>
+      <p:grpSpPr/>
+      <p:sp>
+        <p:nvSpPr>
+          <p:cNvPr id="2" name="Rectangle 1"/>
+          <p:cNvSpPr/>
+          <p:nvPr/>
+        </p:nvSpPr>
+        <p:spPr>
+          <a:xfrm>
+            <a:off x="0" y="0"/>
+            <a:ext cx="12191695" cy="868680"/>
+          </a:xfrm>
+          <a:prstGeom prst="rect">
+            <a:avLst/>
+          </a:prstGeom>
+          <a:solidFill>
+            <a:srgbClr val="102A43"/>
+          </a:solidFill>
+          <a:ln>
+            <a:noFill/>
+          </a:ln>
+          <a:effectLst/>
+        </p:spPr>
+        <p:style>
+          <a:lnRef idx="1">
+            <a:schemeClr val="accent1"/>
+          </a:lnRef>
+          <a:fillRef idx="3">
+            <a:schemeClr val="accent1"/>
+          </a:fillRef>
+          <a:effectRef idx="2">
+            <a:schemeClr val="accent1"/>
+          </a:effectRef>
+          <a:fontRef idx="minor">
+            <a:schemeClr val="lt1"/>
+          </a:fontRef>
+        </p:style>
+        <p:txBody>
+          <a:bodyPr rtlCol="0" anchor="ctr"/>
+          <a:lstStyle/>
+          <a:p>
+            <a:pPr algn="ctr"/>
+          </a:p>
+        </p:txBody>
+      </p:sp>
+      <p:sp>
+        <p:nvSpPr>
+          <p:cNvPr id="3" name="Rectangle 2"/>
+          <p:cNvSpPr/>
+          <p:nvPr/>
+        </p:nvSpPr>
+        <p:spPr>
+          <a:xfrm>
+            <a:off x="0" y="0"/>
+            <a:ext cx="164592" cy="868680"/>
+          </a:xfrm>
+          <a:prstGeom prst="rect">
+            <a:avLst/>
+          </a:prstGeom>
+          <a:solidFill>
+            <a:srgbClr val="0891B2"/>
+          </a:solidFill>
+          <a:ln>
+            <a:noFill/>
+          </a:ln>
+          <a:effectLst/>
+        </p:spPr>
+        <p:style>
+          <a:lnRef idx="1">
+            <a:schemeClr val="accent1"/>
+          </a:lnRef>
+          <a:fillRef idx="3">
+            <a:schemeClr val="accent1"/>
+          </a:fillRef>
+          <a:effectRef idx="2">
+            <a:schemeClr val="accent1"/>
+          </a:effectRef>
+          <a:fontRef idx="minor">
+            <a:schemeClr val="lt1"/>
+          </a:fontRef>
+        </p:style>
+        <p:txBody>
+          <a:bodyPr rtlCol="0" anchor="ctr"/>
+          <a:lstStyle/>
+          <a:p>
+            <a:pPr algn="ctr"/>
+          </a:p>
+        </p:txBody>
+      </p:sp>
+      <p:sp>
+        <p:nvSpPr>
+          <p:cNvPr id="4" name="TextBox 3"/>
+          <p:cNvSpPr txBox="1"/>
+          <p:nvPr/>
+        </p:nvSpPr>
+        <p:spPr>
+          <a:xfrm>
+            <a:off x="411480" y="73152"/>
+            <a:ext cx="10515600" cy="731520"/>
+          </a:xfrm>
+          <a:prstGeom prst="rect">
+            <a:avLst/>
+          </a:prstGeom>
+          <a:noFill/>
+        </p:spPr>
+        <p:txBody>
+          <a:bodyPr wrap="square" anchor="ctr" lIns="50800" rIns="50800">
+            <a:spAutoFit/>
+          </a:bodyPr>
+          <a:lstStyle/>
+          <a:p>
+            <a:pPr algn="l">
+              <a:spcAft>
+                <a:spcPts val="400"/>
+              </a:spcAft>
+            </a:pPr>
+            <a:r>
+              <a:rPr sz="1200" b="1">
+                <a:solidFill>
+                  <a:srgbClr val="0891B2"/>
+                </a:solidFill>
+                <a:latin typeface="Noto Sans CJK SC"/>
+                <a:ea typeface="Noto Sans CJK SC"/>
+              </a:rPr>
+              <a:t>PART 05 · 发展趋势</a:t>
+            </a:r>
+          </a:p>
+          <a:p>
+            <a:pPr algn="l">
+              <a:spcAft>
+                <a:spcPts val="400"/>
+              </a:spcAft>
+            </a:pPr>
+            <a:r>
+              <a:rPr sz="2400" b="1">
+                <a:solidFill>
+                  <a:srgbClr val="FFFFFF"/>
+                </a:solidFill>
+                <a:latin typeface="Noto Sans CJK SC"/>
+                <a:ea typeface="Noto Sans CJK SC"/>
+              </a:rPr>
+              <a:t>VLA 发展趋势总览图</a:t>
+            </a:r>
+          </a:p>
+        </p:txBody>
+      </p:sp>
+      <p:sp>
+        <p:nvSpPr>
+          <p:cNvPr id="5" name="Rounded Rectangle 4"/>
+          <p:cNvSpPr/>
+          <p:nvPr/>
+        </p:nvSpPr>
+        <p:spPr>
+          <a:xfrm>
+            <a:off x="3340261" y="987552"/>
+            <a:ext cx="5511172" cy="5111496"/>
+          </a:xfrm>
+          <a:prstGeom prst="roundRect">
+            <a:avLst/>
+          </a:prstGeom>
+          <a:solidFill>
+            <a:srgbClr val="FFFFFF"/>
+          </a:solidFill>
+          <a:ln w="12700">
+            <a:solidFill>
+              <a:srgbClr val="D0D5DD"/>
+            </a:solidFill>
+          </a:ln>
+          <a:effectLst/>
+        </p:spPr>
+        <p:style>
+          <a:lnRef idx="1">
+            <a:schemeClr val="accent1"/>
+          </a:lnRef>
+          <a:fillRef idx="3">
+            <a:schemeClr val="accent1"/>
+          </a:fillRef>
+          <a:effectRef idx="2">
+            <a:schemeClr val="accent1"/>
+          </a:effectRef>
+          <a:fontRef idx="minor">
+            <a:schemeClr val="lt1"/>
+          </a:fontRef>
+        </p:style>
+        <p:txBody>
+          <a:bodyPr rtlCol="0" anchor="ctr"/>
+          <a:lstStyle/>
+          <a:p>
+            <a:pPr algn="ctr"/>
+          </a:p>
+        </p:txBody>
+      </p:sp>
+      <p:pic>
+        <p:nvPicPr>
+          <p:cNvPr id="6" name="Picture 5" descr="VLA发展趋势.png"/>
+          <p:cNvPicPr>
+            <a:picLocks noChangeAspect="1"/>
+          </p:cNvPicPr>
+          <p:nvPr/>
+        </p:nvPicPr>
+        <p:blipFill>
+          <a:blip r:embed="rId2"/>
+          <a:stretch>
+            <a:fillRect/>
+          </a:stretch>
+        </p:blipFill>
+        <p:spPr>
+          <a:xfrm>
+            <a:off x="3449989" y="1097280"/>
+            <a:ext cx="5291716" cy="4892040"/>
+          </a:xfrm>
+          <a:prstGeom prst="rect">
+            <a:avLst/>
+          </a:prstGeom>
+        </p:spPr>
+      </p:pic>
+      <p:sp>
+        <p:nvSpPr>
+          <p:cNvPr id="7" name="Rounded Rectangle 6"/>
+          <p:cNvSpPr/>
+          <p:nvPr/>
+        </p:nvSpPr>
+        <p:spPr>
+          <a:xfrm>
+            <a:off x="457200" y="6172200"/>
+            <a:ext cx="11247120" cy="502920"/>
+          </a:xfrm>
+          <a:prstGeom prst="roundRect">
+            <a:avLst/>
+          </a:prstGeom>
+          <a:solidFill>
+            <a:srgbClr val="EFF6FF"/>
+          </a:solidFill>
+          <a:ln w="12700">
+            <a:solidFill>
+              <a:srgbClr val="1D4ED8"/>
+            </a:solidFill>
+          </a:ln>
+          <a:effectLst/>
+        </p:spPr>
+        <p:style>
+          <a:lnRef idx="1">
+            <a:schemeClr val="accent1"/>
+          </a:lnRef>
+          <a:fillRef idx="3">
+            <a:schemeClr val="accent1"/>
+          </a:fillRef>
+          <a:effectRef idx="2">
+            <a:schemeClr val="accent1"/>
+          </a:effectRef>
+          <a:fontRef idx="minor">
+            <a:schemeClr val="lt1"/>
+          </a:fontRef>
+        </p:style>
+        <p:txBody>
+          <a:bodyPr rtlCol="0" anchor="ctr"/>
+          <a:lstStyle/>
+          <a:p>
+            <a:pPr algn="ctr"/>
+          </a:p>
+        </p:txBody>
+      </p:sp>
+      <p:sp>
+        <p:nvSpPr>
+          <p:cNvPr id="8" name="TextBox 7"/>
+          <p:cNvSpPr txBox="1"/>
+          <p:nvPr/>
+        </p:nvSpPr>
+        <p:spPr>
+          <a:xfrm>
+            <a:off x="685800" y="6172200"/>
+            <a:ext cx="10881360" cy="502920"/>
+          </a:xfrm>
+          <a:prstGeom prst="rect">
+            <a:avLst/>
+          </a:prstGeom>
+          <a:noFill/>
+        </p:spPr>
+        <p:txBody>
+          <a:bodyPr wrap="square" anchor="ctr" lIns="50800" rIns="50800">
+            <a:spAutoFit/>
+          </a:bodyPr>
+          <a:lstStyle/>
+          <a:p>
+            <a:pPr algn="l">
+              <a:spcAft>
+                <a:spcPts val="400"/>
+              </a:spcAft>
+            </a:pPr>
+            <a:r>
+              <a:rPr sz="1200" b="1">
+                <a:solidFill>
+                  <a:srgbClr val="102A43"/>
+                </a:solidFill>
+                <a:latin typeface="Noto Sans CJK SC"/>
+                <a:ea typeface="Noto Sans CJK SC"/>
+              </a:rPr>
+              <a:t>图：VLA 发展趋势总览（来源：reports/VLA发展趋势.png）</a:t>
+            </a:r>
+          </a:p>
+        </p:txBody>
+      </p:sp>
+      <p:sp>
+        <p:nvSpPr>
+          <p:cNvPr id="9" name="TextBox 8"/>
+          <p:cNvSpPr txBox="1"/>
+          <p:nvPr/>
+        </p:nvSpPr>
+        <p:spPr>
+          <a:xfrm>
+            <a:off x="365760" y="6446520"/>
+            <a:ext cx="5486400" cy="320040"/>
+          </a:xfrm>
+          <a:prstGeom prst="rect">
+            <a:avLst/>
+          </a:prstGeom>
+          <a:noFill/>
+        </p:spPr>
+        <p:txBody>
+          <a:bodyPr wrap="square" anchor="t" lIns="50800" rIns="50800">
+            <a:spAutoFit/>
+          </a:bodyPr>
+          <a:lstStyle/>
+          <a:p>
+            <a:pPr algn="l">
+              <a:spcAft>
+                <a:spcPts val="400"/>
+              </a:spcAft>
+            </a:pPr>
+            <a:r>
+              <a:rPr sz="1000" b="0">
+                <a:solidFill>
+                  <a:srgbClr val="475467"/>
+                </a:solidFill>
+                <a:latin typeface="Noto Sans CJK SC"/>
+                <a:ea typeface="Noto Sans CJK SC"/>
+              </a:rPr>
+              <a:t>VLA 大模型技术分享报告</a:t>
+            </a:r>
+          </a:p>
+        </p:txBody>
+      </p:sp>
+      <p:sp>
+        <p:nvSpPr>
+          <p:cNvPr id="10" name="TextBox 9"/>
+          <p:cNvSpPr txBox="1"/>
+          <p:nvPr/>
+        </p:nvSpPr>
+        <p:spPr>
+          <a:xfrm>
+            <a:off x="11094415" y="6446520"/>
+            <a:ext cx="914400" cy="320040"/>
+          </a:xfrm>
+          <a:prstGeom prst="rect">
+            <a:avLst/>
+          </a:prstGeom>
+          <a:noFill/>
+        </p:spPr>
+        <p:txBody>
+          <a:bodyPr wrap="square" anchor="t" lIns="50800" rIns="50800">
+            <a:spAutoFit/>
+          </a:bodyPr>
+          <a:lstStyle/>
+          <a:p>
+            <a:pPr algn="r">
+              <a:spcAft>
+                <a:spcPts val="400"/>
+              </a:spcAft>
+            </a:pPr>
+            <a:r>
+              <a:rPr sz="1100" b="0">
+                <a:solidFill>
+                  <a:srgbClr val="475467"/>
+                </a:solidFill>
+                <a:latin typeface="Noto Sans CJK SC"/>
+                <a:ea typeface="Noto Sans CJK SC"/>
+              </a:rPr>
+              <a:t>25</a:t>
             </a:r>
           </a:p>
         </p:txBody>

</xml_diff>

<commit_message>
Add WAIC embodied-AI roundtable summary slide to PPT Part 5
</commit_message>
<xml_diff>
--- a/reports/VLA大模型技术分享报告.pptx
+++ b/reports/VLA大模型技术分享报告.pptx
@@ -30,6 +30,7 @@
     <p:sldId id="278" r:id="rId29"/>
     <p:sldId id="279" r:id="rId30"/>
     <p:sldId id="282" r:id="rId33"/>
+    <p:sldId id="283" r:id="rId34"/>
     <p:sldId id="280" r:id="rId31"/>
     <p:sldId id="281" r:id="rId32"/>
   </p:sldIdLst>
@@ -18430,7 +18431,7 @@
                 <a:latin typeface="Noto Sans CJK SC"/>
                 <a:ea typeface="Noto Sans CJK SC"/>
               </a:rPr>
-              <a:t>SUMMARY</a:t>
+              <a:t>PART 05 · 发展趋势</a:t>
             </a:r>
           </a:p>
           <a:p>
@@ -18447,7 +18448,7 @@
                 <a:latin typeface="Noto Sans CJK SC"/>
                 <a:ea typeface="Noto Sans CJK SC"/>
               </a:rPr>
-              <a:t>总结与讨论</a:t>
+              <a:t>VLA 发展趋势总览图</a:t>
             </a:r>
           </a:p>
         </p:txBody>
@@ -18460,8 +18461,78 @@
         </p:nvSpPr>
         <p:spPr>
           <a:xfrm>
-            <a:off x="457200" y="1188720"/>
-            <a:ext cx="11247120" cy="1005840"/>
+            <a:off x="3340261" y="987552"/>
+            <a:ext cx="5511172" cy="5111496"/>
+          </a:xfrm>
+          <a:prstGeom prst="roundRect">
+            <a:avLst/>
+          </a:prstGeom>
+          <a:solidFill>
+            <a:srgbClr val="FFFFFF"/>
+          </a:solidFill>
+          <a:ln w="12700">
+            <a:solidFill>
+              <a:srgbClr val="D0D5DD"/>
+            </a:solidFill>
+          </a:ln>
+          <a:effectLst/>
+        </p:spPr>
+        <p:style>
+          <a:lnRef idx="1">
+            <a:schemeClr val="accent1"/>
+          </a:lnRef>
+          <a:fillRef idx="3">
+            <a:schemeClr val="accent1"/>
+          </a:fillRef>
+          <a:effectRef idx="2">
+            <a:schemeClr val="accent1"/>
+          </a:effectRef>
+          <a:fontRef idx="minor">
+            <a:schemeClr val="lt1"/>
+          </a:fontRef>
+        </p:style>
+        <p:txBody>
+          <a:bodyPr rtlCol="0" anchor="ctr"/>
+          <a:lstStyle/>
+          <a:p>
+            <a:pPr algn="ctr"/>
+          </a:p>
+        </p:txBody>
+      </p:sp>
+      <p:pic>
+        <p:nvPicPr>
+          <p:cNvPr id="6" name="Picture 5" descr="VLA发展趋势.png"/>
+          <p:cNvPicPr>
+            <a:picLocks noChangeAspect="1"/>
+          </p:cNvPicPr>
+          <p:nvPr/>
+        </p:nvPicPr>
+        <p:blipFill>
+          <a:blip r:embed="rId2"/>
+          <a:stretch>
+            <a:fillRect/>
+          </a:stretch>
+        </p:blipFill>
+        <p:spPr>
+          <a:xfrm>
+            <a:off x="3449989" y="1097280"/>
+            <a:ext cx="5291716" cy="4892040"/>
+          </a:xfrm>
+          <a:prstGeom prst="rect">
+            <a:avLst/>
+          </a:prstGeom>
+        </p:spPr>
+      </p:pic>
+      <p:sp>
+        <p:nvSpPr>
+          <p:cNvPr id="7" name="Rounded Rectangle 6"/>
+          <p:cNvSpPr/>
+          <p:nvPr/>
+        </p:nvSpPr>
+        <p:spPr>
+          <a:xfrm>
+            <a:off x="457200" y="6172200"/>
+            <a:ext cx="11247120" cy="502920"/>
           </a:xfrm>
           <a:prstGeom prst="roundRect">
             <a:avLst/>
@@ -18500,14 +18571,54 @@
       </p:sp>
       <p:sp>
         <p:nvSpPr>
-          <p:cNvPr id="6" name="TextBox 5"/>
+          <p:cNvPr id="8" name="TextBox 7"/>
           <p:cNvSpPr txBox="1"/>
           <p:nvPr/>
         </p:nvSpPr>
         <p:spPr>
           <a:xfrm>
-            <a:off x="685800" y="1261872"/>
-            <a:ext cx="10881360" cy="411480"/>
+            <a:off x="685800" y="6172200"/>
+            <a:ext cx="10881360" cy="502920"/>
+          </a:xfrm>
+          <a:prstGeom prst="rect">
+            <a:avLst/>
+          </a:prstGeom>
+          <a:noFill/>
+        </p:spPr>
+        <p:txBody>
+          <a:bodyPr wrap="square" anchor="ctr" lIns="50800" rIns="50800">
+            <a:spAutoFit/>
+          </a:bodyPr>
+          <a:lstStyle/>
+          <a:p>
+            <a:pPr algn="l">
+              <a:spcAft>
+                <a:spcPts val="400"/>
+              </a:spcAft>
+            </a:pPr>
+            <a:r>
+              <a:rPr sz="1200" b="1">
+                <a:solidFill>
+                  <a:srgbClr val="102A43"/>
+                </a:solidFill>
+                <a:latin typeface="Noto Sans CJK SC"/>
+                <a:ea typeface="Noto Sans CJK SC"/>
+              </a:rPr>
+              <a:t>图：VLA 发展趋势总览（来源：reports/VLA发展趋势.png）</a:t>
+            </a:r>
+          </a:p>
+        </p:txBody>
+      </p:sp>
+      <p:sp>
+        <p:nvSpPr>
+          <p:cNvPr id="9" name="TextBox 8"/>
+          <p:cNvSpPr txBox="1"/>
+          <p:nvPr/>
+        </p:nvSpPr>
+        <p:spPr>
+          <a:xfrm>
+            <a:off x="365760" y="6446520"/>
+            <a:ext cx="5486400" cy="320040"/>
           </a:xfrm>
           <a:prstGeom prst="rect">
             <a:avLst/>
@@ -18526,28 +18637,28 @@
               </a:spcAft>
             </a:pPr>
             <a:r>
-              <a:rPr sz="1450" b="1">
-                <a:solidFill>
-                  <a:srgbClr val="102A43"/>
-                </a:solidFill>
-                <a:latin typeface="Noto Sans CJK SC"/>
-                <a:ea typeface="Noto Sans CJK SC"/>
-              </a:rPr>
-              <a:t>1. 范式确立</a:t>
-            </a:r>
-          </a:p>
-        </p:txBody>
-      </p:sp>
-      <p:sp>
-        <p:nvSpPr>
-          <p:cNvPr id="7" name="TextBox 6"/>
+              <a:rPr sz="1000" b="0">
+                <a:solidFill>
+                  <a:srgbClr val="475467"/>
+                </a:solidFill>
+                <a:latin typeface="Noto Sans CJK SC"/>
+                <a:ea typeface="Noto Sans CJK SC"/>
+              </a:rPr>
+              <a:t>VLA 大模型技术分享报告</a:t>
+            </a:r>
+          </a:p>
+        </p:txBody>
+      </p:sp>
+      <p:sp>
+        <p:nvSpPr>
+          <p:cNvPr id="10" name="TextBox 9"/>
           <p:cNvSpPr txBox="1"/>
           <p:nvPr/>
         </p:nvSpPr>
         <p:spPr>
           <a:xfrm>
-            <a:off x="685800" y="1645920"/>
-            <a:ext cx="10881360" cy="502920"/>
+            <a:off x="11094415" y="6446520"/>
+            <a:ext cx="914400" cy="320040"/>
           </a:xfrm>
           <a:prstGeom prst="rect">
             <a:avLst/>
@@ -18560,532 +18671,20 @@
           </a:bodyPr>
           <a:lstStyle/>
           <a:p>
-            <a:pPr algn="l">
-              <a:spcAft>
-                <a:spcPts val="400"/>
-              </a:spcAft>
-            </a:pPr>
-            <a:r>
-              <a:rPr sz="1150" b="0">
+            <a:pPr algn="r">
+              <a:spcAft>
+                <a:spcPts val="400"/>
+              </a:spcAft>
+            </a:pPr>
+            <a:r>
+              <a:rPr sz="1100" b="0">
                 <a:solidFill>
                   <a:srgbClr val="475467"/>
                 </a:solidFill>
                 <a:latin typeface="Noto Sans CJK SC"/>
                 <a:ea typeface="Noto Sans CJK SC"/>
               </a:rPr>
-              <a:t>VLA 已从概念（RT-2, 2023）走到可用开源基座（π0、GR00T N1, 2024–25）：VLM 骨干 + 流匹配动作专家 + 动作分块是当前最优配方</a:t>
-            </a:r>
-          </a:p>
-        </p:txBody>
-      </p:sp>
-      <p:sp>
-        <p:nvSpPr>
-          <p:cNvPr id="8" name="Rounded Rectangle 7"/>
-          <p:cNvSpPr/>
-          <p:nvPr/>
-        </p:nvSpPr>
-        <p:spPr>
-          <a:xfrm>
-            <a:off x="457200" y="2331720"/>
-            <a:ext cx="11247120" cy="1005840"/>
-          </a:xfrm>
-          <a:prstGeom prst="roundRect">
-            <a:avLst/>
-          </a:prstGeom>
-          <a:solidFill>
-            <a:srgbClr val="FFFFFF"/>
-          </a:solidFill>
-          <a:ln w="12700">
-            <a:solidFill>
-              <a:srgbClr val="1D4ED8"/>
-            </a:solidFill>
-          </a:ln>
-          <a:effectLst/>
-        </p:spPr>
-        <p:style>
-          <a:lnRef idx="1">
-            <a:schemeClr val="accent1"/>
-          </a:lnRef>
-          <a:fillRef idx="3">
-            <a:schemeClr val="accent1"/>
-          </a:fillRef>
-          <a:effectRef idx="2">
-            <a:schemeClr val="accent1"/>
-          </a:effectRef>
-          <a:fontRef idx="minor">
-            <a:schemeClr val="lt1"/>
-          </a:fontRef>
-        </p:style>
-        <p:txBody>
-          <a:bodyPr rtlCol="0" anchor="ctr"/>
-          <a:lstStyle/>
-          <a:p>
-            <a:pPr algn="ctr"/>
-          </a:p>
-        </p:txBody>
-      </p:sp>
-      <p:sp>
-        <p:nvSpPr>
-          <p:cNvPr id="9" name="TextBox 8"/>
-          <p:cNvSpPr txBox="1"/>
-          <p:nvPr/>
-        </p:nvSpPr>
-        <p:spPr>
-          <a:xfrm>
-            <a:off x="685800" y="2404872"/>
-            <a:ext cx="10881360" cy="411480"/>
-          </a:xfrm>
-          <a:prstGeom prst="rect">
-            <a:avLst/>
-          </a:prstGeom>
-          <a:noFill/>
-        </p:spPr>
-        <p:txBody>
-          <a:bodyPr wrap="square" anchor="t" lIns="50800" rIns="50800">
-            <a:spAutoFit/>
-          </a:bodyPr>
-          <a:lstStyle/>
-          <a:p>
-            <a:pPr algn="l">
-              <a:spcAft>
-                <a:spcPts val="400"/>
-              </a:spcAft>
-            </a:pPr>
-            <a:r>
-              <a:rPr sz="1450" b="1">
-                <a:solidFill>
-                  <a:srgbClr val="102A43"/>
-                </a:solidFill>
-                <a:latin typeface="Noto Sans CJK SC"/>
-                <a:ea typeface="Noto Sans CJK SC"/>
-              </a:rPr>
-              <a:t>2. 四个项目的互补启示</a:t>
-            </a:r>
-          </a:p>
-        </p:txBody>
-      </p:sp>
-      <p:sp>
-        <p:nvSpPr>
-          <p:cNvPr id="10" name="TextBox 9"/>
-          <p:cNvSpPr txBox="1"/>
-          <p:nvPr/>
-        </p:nvSpPr>
-        <p:spPr>
-          <a:xfrm>
-            <a:off x="685800" y="2788920"/>
-            <a:ext cx="10881360" cy="502920"/>
-          </a:xfrm>
-          <a:prstGeom prst="rect">
-            <a:avLst/>
-          </a:prstGeom>
-          <a:noFill/>
-        </p:spPr>
-        <p:txBody>
-          <a:bodyPr wrap="square" anchor="t" lIns="50800" rIns="50800">
-            <a:spAutoFit/>
-          </a:bodyPr>
-          <a:lstStyle/>
-          <a:p>
-            <a:pPr algn="l">
-              <a:spcAft>
-                <a:spcPts val="400"/>
-              </a:spcAft>
-            </a:pPr>
-            <a:r>
-              <a:rPr sz="1150" b="0">
-                <a:solidFill>
-                  <a:srgbClr val="475467"/>
-                </a:solidFill>
-                <a:latin typeface="Noto Sans CJK SC"/>
-                <a:ea typeface="Noto Sans CJK SC"/>
-              </a:rPr>
-              <a:t>RT 系证明规模与语义涌现；ACT 提供高频精细控制与低成本数据采集范式；π0 给出通用基座+微调的完整工程栈；GR00T 展示数据金字塔与全栈生态打法</a:t>
-            </a:r>
-          </a:p>
-        </p:txBody>
-      </p:sp>
-      <p:sp>
-        <p:nvSpPr>
-          <p:cNvPr id="11" name="Rounded Rectangle 10"/>
-          <p:cNvSpPr/>
-          <p:nvPr/>
-        </p:nvSpPr>
-        <p:spPr>
-          <a:xfrm>
-            <a:off x="457200" y="3474720"/>
-            <a:ext cx="11247120" cy="1005840"/>
-          </a:xfrm>
-          <a:prstGeom prst="roundRect">
-            <a:avLst/>
-          </a:prstGeom>
-          <a:solidFill>
-            <a:srgbClr val="EFF6FF"/>
-          </a:solidFill>
-          <a:ln w="12700">
-            <a:solidFill>
-              <a:srgbClr val="1D4ED8"/>
-            </a:solidFill>
-          </a:ln>
-          <a:effectLst/>
-        </p:spPr>
-        <p:style>
-          <a:lnRef idx="1">
-            <a:schemeClr val="accent1"/>
-          </a:lnRef>
-          <a:fillRef idx="3">
-            <a:schemeClr val="accent1"/>
-          </a:fillRef>
-          <a:effectRef idx="2">
-            <a:schemeClr val="accent1"/>
-          </a:effectRef>
-          <a:fontRef idx="minor">
-            <a:schemeClr val="lt1"/>
-          </a:fontRef>
-        </p:style>
-        <p:txBody>
-          <a:bodyPr rtlCol="0" anchor="ctr"/>
-          <a:lstStyle/>
-          <a:p>
-            <a:pPr algn="ctr"/>
-          </a:p>
-        </p:txBody>
-      </p:sp>
-      <p:sp>
-        <p:nvSpPr>
-          <p:cNvPr id="12" name="TextBox 11"/>
-          <p:cNvSpPr txBox="1"/>
-          <p:nvPr/>
-        </p:nvSpPr>
-        <p:spPr>
-          <a:xfrm>
-            <a:off x="685800" y="3547872"/>
-            <a:ext cx="10881360" cy="411480"/>
-          </a:xfrm>
-          <a:prstGeom prst="rect">
-            <a:avLst/>
-          </a:prstGeom>
-          <a:noFill/>
-        </p:spPr>
-        <p:txBody>
-          <a:bodyPr wrap="square" anchor="t" lIns="50800" rIns="50800">
-            <a:spAutoFit/>
-          </a:bodyPr>
-          <a:lstStyle/>
-          <a:p>
-            <a:pPr algn="l">
-              <a:spcAft>
-                <a:spcPts val="400"/>
-              </a:spcAft>
-            </a:pPr>
-            <a:r>
-              <a:rPr sz="1450" b="1">
-                <a:solidFill>
-                  <a:srgbClr val="102A43"/>
-                </a:solidFill>
-                <a:latin typeface="Noto Sans CJK SC"/>
-                <a:ea typeface="Noto Sans CJK SC"/>
-              </a:rPr>
-              <a:t>3. 工程主线</a:t>
-            </a:r>
-          </a:p>
-        </p:txBody>
-      </p:sp>
-      <p:sp>
-        <p:nvSpPr>
-          <p:cNvPr id="13" name="TextBox 12"/>
-          <p:cNvSpPr txBox="1"/>
-          <p:nvPr/>
-        </p:nvSpPr>
-        <p:spPr>
-          <a:xfrm>
-            <a:off x="685800" y="3931920"/>
-            <a:ext cx="10881360" cy="502920"/>
-          </a:xfrm>
-          <a:prstGeom prst="rect">
-            <a:avLst/>
-          </a:prstGeom>
-          <a:noFill/>
-        </p:spPr>
-        <p:txBody>
-          <a:bodyPr wrap="square" anchor="t" lIns="50800" rIns="50800">
-            <a:spAutoFit/>
-          </a:bodyPr>
-          <a:lstStyle/>
-          <a:p>
-            <a:pPr algn="l">
-              <a:spcAft>
-                <a:spcPts val="400"/>
-              </a:spcAft>
-            </a:pPr>
-            <a:r>
-              <a:rPr sz="1150" b="0">
-                <a:solidFill>
-                  <a:srgbClr val="475467"/>
-                </a:solidFill>
-                <a:latin typeface="Noto Sans CJK SC"/>
-                <a:ea typeface="Noto Sans CJK SC"/>
-              </a:rPr>
-              <a:t>数据工程占 60% 以上工作量；两阶段训练（预训练+后训练）；动作分块摊销推理延迟；三级评测 + 数据飞轮闭环持续迭代</a:t>
-            </a:r>
-          </a:p>
-        </p:txBody>
-      </p:sp>
-      <p:sp>
-        <p:nvSpPr>
-          <p:cNvPr id="14" name="Rounded Rectangle 13"/>
-          <p:cNvSpPr/>
-          <p:nvPr/>
-        </p:nvSpPr>
-        <p:spPr>
-          <a:xfrm>
-            <a:off x="457200" y="4617720"/>
-            <a:ext cx="11247120" cy="1005840"/>
-          </a:xfrm>
-          <a:prstGeom prst="roundRect">
-            <a:avLst/>
-          </a:prstGeom>
-          <a:solidFill>
-            <a:srgbClr val="FFFFFF"/>
-          </a:solidFill>
-          <a:ln w="12700">
-            <a:solidFill>
-              <a:srgbClr val="1D4ED8"/>
-            </a:solidFill>
-          </a:ln>
-          <a:effectLst/>
-        </p:spPr>
-        <p:style>
-          <a:lnRef idx="1">
-            <a:schemeClr val="accent1"/>
-          </a:lnRef>
-          <a:fillRef idx="3">
-            <a:schemeClr val="accent1"/>
-          </a:fillRef>
-          <a:effectRef idx="2">
-            <a:schemeClr val="accent1"/>
-          </a:effectRef>
-          <a:fontRef idx="minor">
-            <a:schemeClr val="lt1"/>
-          </a:fontRef>
-        </p:style>
-        <p:txBody>
-          <a:bodyPr rtlCol="0" anchor="ctr"/>
-          <a:lstStyle/>
-          <a:p>
-            <a:pPr algn="ctr"/>
-          </a:p>
-        </p:txBody>
-      </p:sp>
-      <p:sp>
-        <p:nvSpPr>
-          <p:cNvPr id="15" name="TextBox 14"/>
-          <p:cNvSpPr txBox="1"/>
-          <p:nvPr/>
-        </p:nvSpPr>
-        <p:spPr>
-          <a:xfrm>
-            <a:off x="685800" y="4690872"/>
-            <a:ext cx="10881360" cy="411480"/>
-          </a:xfrm>
-          <a:prstGeom prst="rect">
-            <a:avLst/>
-          </a:prstGeom>
-          <a:noFill/>
-        </p:spPr>
-        <p:txBody>
-          <a:bodyPr wrap="square" anchor="t" lIns="50800" rIns="50800">
-            <a:spAutoFit/>
-          </a:bodyPr>
-          <a:lstStyle/>
-          <a:p>
-            <a:pPr algn="l">
-              <a:spcAft>
-                <a:spcPts val="400"/>
-              </a:spcAft>
-            </a:pPr>
-            <a:r>
-              <a:rPr sz="1450" b="1">
-                <a:solidFill>
-                  <a:srgbClr val="102A43"/>
-                </a:solidFill>
-                <a:latin typeface="Noto Sans CJK SC"/>
-                <a:ea typeface="Noto Sans CJK SC"/>
-              </a:rPr>
-              <a:t>4. 理性判断</a:t>
-            </a:r>
-          </a:p>
-        </p:txBody>
-      </p:sp>
-      <p:sp>
-        <p:nvSpPr>
-          <p:cNvPr id="16" name="TextBox 15"/>
-          <p:cNvSpPr txBox="1"/>
-          <p:nvPr/>
-        </p:nvSpPr>
-        <p:spPr>
-          <a:xfrm>
-            <a:off x="685800" y="5074920"/>
-            <a:ext cx="10881360" cy="502920"/>
-          </a:xfrm>
-          <a:prstGeom prst="rect">
-            <a:avLst/>
-          </a:prstGeom>
-          <a:noFill/>
-        </p:spPr>
-        <p:txBody>
-          <a:bodyPr wrap="square" anchor="t" lIns="50800" rIns="50800">
-            <a:spAutoFit/>
-          </a:bodyPr>
-          <a:lstStyle/>
-          <a:p>
-            <a:pPr algn="l">
-              <a:spcAft>
-                <a:spcPts val="400"/>
-              </a:spcAft>
-            </a:pPr>
-            <a:r>
-              <a:rPr sz="1150" b="0">
-                <a:solidFill>
-                  <a:srgbClr val="475467"/>
-                </a:solidFill>
-                <a:latin typeface="Noto Sans CJK SC"/>
-                <a:ea typeface="Noto Sans CJK SC"/>
-              </a:rPr>
-              <a:t>VLA 与传统控制是互补而非替代；泛化、安全、实时性仍是落地三大挑战；建议以开源基座（openpi/GR00T）+ 自有场景数据微调作为切入路径</a:t>
-            </a:r>
-          </a:p>
-        </p:txBody>
-      </p:sp>
-      <p:sp>
-        <p:nvSpPr>
-          <p:cNvPr id="17" name="Rounded Rectangle 16"/>
-          <p:cNvSpPr/>
-          <p:nvPr/>
-        </p:nvSpPr>
-        <p:spPr>
-          <a:xfrm>
-            <a:off x="457200" y="5897880"/>
-            <a:ext cx="11247120" cy="594360"/>
-          </a:xfrm>
-          <a:prstGeom prst="roundRect">
-            <a:avLst/>
-          </a:prstGeom>
-          <a:solidFill>
-            <a:srgbClr val="102A43"/>
-          </a:solidFill>
-          <a:ln>
-            <a:noFill/>
-          </a:ln>
-          <a:effectLst/>
-        </p:spPr>
-        <p:style>
-          <a:lnRef idx="1">
-            <a:schemeClr val="accent1"/>
-          </a:lnRef>
-          <a:fillRef idx="3">
-            <a:schemeClr val="accent1"/>
-          </a:fillRef>
-          <a:effectRef idx="2">
-            <a:schemeClr val="accent1"/>
-          </a:effectRef>
-          <a:fontRef idx="minor">
-            <a:schemeClr val="lt1"/>
-          </a:fontRef>
-        </p:style>
-        <p:txBody>
-          <a:bodyPr rtlCol="0" anchor="ctr" wrap="square" lIns="50800" rIns="50800" tIns="25400" bIns="25400"/>
-          <a:lstStyle/>
-          <a:p>
-            <a:pPr algn="ctr"/>
-            <a:r>
-              <a:rPr sz="1200" b="0">
-                <a:solidFill>
-                  <a:srgbClr val="93C5FD"/>
-                </a:solidFill>
-                <a:latin typeface="Noto Sans CJK SC"/>
-                <a:ea typeface="Noto Sans CJK SC"/>
-              </a:rPr>
-              <a:t>参考项目：github.com/MarkFzp/act-plus-plus · NVIDIA/Isaac-GR00T · Physical-Intelligence/openpi · google-research/robotics_transformer</a:t>
-            </a:r>
-          </a:p>
-        </p:txBody>
-      </p:sp>
-      <p:sp>
-        <p:nvSpPr>
-          <p:cNvPr id="18" name="TextBox 17"/>
-          <p:cNvSpPr txBox="1"/>
-          <p:nvPr/>
-        </p:nvSpPr>
-        <p:spPr>
-          <a:xfrm>
-            <a:off x="11094415" y="6446520"/>
-            <a:ext cx="914400" cy="320040"/>
-          </a:xfrm>
-          <a:prstGeom prst="rect">
-            <a:avLst/>
-          </a:prstGeom>
-          <a:noFill/>
-        </p:spPr>
-        <p:txBody>
-          <a:bodyPr wrap="square" anchor="t" lIns="50800" rIns="50800">
-            <a:spAutoFit/>
-          </a:bodyPr>
-          <a:lstStyle/>
-          <a:p>
-            <a:pPr algn="r">
-              <a:spcAft>
-                <a:spcPts val="400"/>
-              </a:spcAft>
-            </a:pPr>
-            <a:r>
-              <a:rPr sz="1100" b="0">
-                <a:solidFill>
-                  <a:srgbClr val="475467"/>
-                </a:solidFill>
-                <a:latin typeface="Noto Sans CJK SC"/>
-                <a:ea typeface="Noto Sans CJK SC"/>
-              </a:rPr>
-              <a:t>26</a:t>
-            </a:r>
-          </a:p>
-        </p:txBody>
-      </p:sp>
-      <p:sp>
-        <p:nvSpPr>
-          <p:cNvPr id="19" name="TextBox 18"/>
-          <p:cNvSpPr txBox="1"/>
-          <p:nvPr/>
-        </p:nvSpPr>
-        <p:spPr>
-          <a:xfrm>
-            <a:off x="365760" y="6446520"/>
-            <a:ext cx="5486400" cy="320040"/>
-          </a:xfrm>
-          <a:prstGeom prst="rect">
-            <a:avLst/>
-          </a:prstGeom>
-          <a:noFill/>
-        </p:spPr>
-        <p:txBody>
-          <a:bodyPr wrap="square" anchor="t" lIns="50800" rIns="50800">
-            <a:spAutoFit/>
-          </a:bodyPr>
-          <a:lstStyle/>
-          <a:p>
-            <a:pPr algn="l">
-              <a:spcAft>
-                <a:spcPts val="400"/>
-              </a:spcAft>
-            </a:pPr>
-            <a:r>
-              <a:rPr sz="1000" b="0">
-                <a:solidFill>
-                  <a:srgbClr val="475467"/>
-                </a:solidFill>
-                <a:latin typeface="Noto Sans CJK SC"/>
-                <a:ea typeface="Noto Sans CJK SC"/>
-              </a:rPr>
-              <a:t>VLA 大模型技术分享报告</a:t>
+              <a:t>25</a:t>
             </a:r>
           </a:p>
         </p:txBody>
@@ -19117,7 +18716,7 @@
         <p:spPr>
           <a:xfrm>
             <a:off x="0" y="0"/>
-            <a:ext cx="12191695" cy="6858000"/>
+            <a:ext cx="12191695" cy="868680"/>
           </a:xfrm>
           <a:prstGeom prst="rect">
             <a:avLst/>
@@ -19160,8 +18759,8 @@
         </p:nvSpPr>
         <p:spPr>
           <a:xfrm>
-            <a:off x="0" y="3108960"/>
-            <a:ext cx="12191695" cy="54864"/>
+            <a:off x="0" y="0"/>
+            <a:ext cx="164592" cy="868680"/>
           </a:xfrm>
           <a:prstGeom prst="rect">
             <a:avLst/>
@@ -19204,8 +18803,111 @@
         </p:nvSpPr>
         <p:spPr>
           <a:xfrm>
-            <a:off x="0" y="2286000"/>
-            <a:ext cx="12191695" cy="914400"/>
+            <a:off x="411480" y="73152"/>
+            <a:ext cx="10515600" cy="731520"/>
+          </a:xfrm>
+          <a:prstGeom prst="rect">
+            <a:avLst/>
+          </a:prstGeom>
+          <a:noFill/>
+        </p:spPr>
+        <p:txBody>
+          <a:bodyPr wrap="square" anchor="ctr" lIns="50800" rIns="50800">
+            <a:spAutoFit/>
+          </a:bodyPr>
+          <a:lstStyle/>
+          <a:p>
+            <a:pPr algn="l">
+              <a:spcAft>
+                <a:spcPts val="400"/>
+              </a:spcAft>
+            </a:pPr>
+            <a:r>
+              <a:rPr sz="1200" b="1">
+                <a:solidFill>
+                  <a:srgbClr val="0891B2"/>
+                </a:solidFill>
+                <a:latin typeface="Noto Sans CJK SC"/>
+                <a:ea typeface="Noto Sans CJK SC"/>
+              </a:rPr>
+              <a:t>SUMMARY</a:t>
+            </a:r>
+          </a:p>
+          <a:p>
+            <a:pPr algn="l">
+              <a:spcAft>
+                <a:spcPts val="400"/>
+              </a:spcAft>
+            </a:pPr>
+            <a:r>
+              <a:rPr sz="2400" b="1">
+                <a:solidFill>
+                  <a:srgbClr val="FFFFFF"/>
+                </a:solidFill>
+                <a:latin typeface="Noto Sans CJK SC"/>
+                <a:ea typeface="Noto Sans CJK SC"/>
+              </a:rPr>
+              <a:t>总结与讨论</a:t>
+            </a:r>
+          </a:p>
+        </p:txBody>
+      </p:sp>
+      <p:sp>
+        <p:nvSpPr>
+          <p:cNvPr id="5" name="Rounded Rectangle 4"/>
+          <p:cNvSpPr/>
+          <p:nvPr/>
+        </p:nvSpPr>
+        <p:spPr>
+          <a:xfrm>
+            <a:off x="457200" y="1188720"/>
+            <a:ext cx="11247120" cy="1005840"/>
+          </a:xfrm>
+          <a:prstGeom prst="roundRect">
+            <a:avLst/>
+          </a:prstGeom>
+          <a:solidFill>
+            <a:srgbClr val="EFF6FF"/>
+          </a:solidFill>
+          <a:ln w="12700">
+            <a:solidFill>
+              <a:srgbClr val="1D4ED8"/>
+            </a:solidFill>
+          </a:ln>
+          <a:effectLst/>
+        </p:spPr>
+        <p:style>
+          <a:lnRef idx="1">
+            <a:schemeClr val="accent1"/>
+          </a:lnRef>
+          <a:fillRef idx="3">
+            <a:schemeClr val="accent1"/>
+          </a:fillRef>
+          <a:effectRef idx="2">
+            <a:schemeClr val="accent1"/>
+          </a:effectRef>
+          <a:fontRef idx="minor">
+            <a:schemeClr val="lt1"/>
+          </a:fontRef>
+        </p:style>
+        <p:txBody>
+          <a:bodyPr rtlCol="0" anchor="ctr"/>
+          <a:lstStyle/>
+          <a:p>
+            <a:pPr algn="ctr"/>
+          </a:p>
+        </p:txBody>
+      </p:sp>
+      <p:sp>
+        <p:nvSpPr>
+          <p:cNvPr id="6" name="TextBox 5"/>
+          <p:cNvSpPr txBox="1"/>
+          <p:nvPr/>
+        </p:nvSpPr>
+        <p:spPr>
+          <a:xfrm>
+            <a:off x="685800" y="1261872"/>
+            <a:ext cx="10881360" cy="411480"/>
           </a:xfrm>
           <a:prstGeom prst="rect">
             <a:avLst/>
@@ -19218,34 +18920,34 @@
           </a:bodyPr>
           <a:lstStyle/>
           <a:p>
-            <a:pPr algn="ctr">
-              <a:spcAft>
-                <a:spcPts val="400"/>
-              </a:spcAft>
-            </a:pPr>
-            <a:r>
-              <a:rPr sz="4400" b="1">
-                <a:solidFill>
-                  <a:srgbClr val="FFFFFF"/>
-                </a:solidFill>
-                <a:latin typeface="Noto Sans CJK SC"/>
-                <a:ea typeface="Noto Sans CJK SC"/>
-              </a:rPr>
-              <a:t>谢 谢 · Q &amp; A</a:t>
-            </a:r>
-          </a:p>
-        </p:txBody>
-      </p:sp>
-      <p:sp>
-        <p:nvSpPr>
-          <p:cNvPr id="5" name="TextBox 4"/>
+            <a:pPr algn="l">
+              <a:spcAft>
+                <a:spcPts val="400"/>
+              </a:spcAft>
+            </a:pPr>
+            <a:r>
+              <a:rPr sz="1450" b="1">
+                <a:solidFill>
+                  <a:srgbClr val="102A43"/>
+                </a:solidFill>
+                <a:latin typeface="Noto Sans CJK SC"/>
+                <a:ea typeface="Noto Sans CJK SC"/>
+              </a:rPr>
+              <a:t>1. 范式确立</a:t>
+            </a:r>
+          </a:p>
+        </p:txBody>
+      </p:sp>
+      <p:sp>
+        <p:nvSpPr>
+          <p:cNvPr id="7" name="TextBox 6"/>
           <p:cNvSpPr txBox="1"/>
           <p:nvPr/>
         </p:nvSpPr>
         <p:spPr>
           <a:xfrm>
-            <a:off x="0" y="3383280"/>
-            <a:ext cx="12191695" cy="548640"/>
+            <a:off x="685800" y="1645920"/>
+            <a:ext cx="10881360" cy="502920"/>
           </a:xfrm>
           <a:prstGeom prst="rect">
             <a:avLst/>
@@ -19258,20 +18960,532 @@
           </a:bodyPr>
           <a:lstStyle/>
           <a:p>
-            <a:pPr algn="ctr">
-              <a:spcAft>
-                <a:spcPts val="400"/>
-              </a:spcAft>
-            </a:pPr>
-            <a:r>
-              <a:rPr sz="1600" b="0">
+            <a:pPr algn="l">
+              <a:spcAft>
+                <a:spcPts val="400"/>
+              </a:spcAft>
+            </a:pPr>
+            <a:r>
+              <a:rPr sz="1150" b="0">
+                <a:solidFill>
+                  <a:srgbClr val="475467"/>
+                </a:solidFill>
+                <a:latin typeface="Noto Sans CJK SC"/>
+                <a:ea typeface="Noto Sans CJK SC"/>
+              </a:rPr>
+              <a:t>VLA 已从概念（RT-2, 2023）走到可用开源基座（π0、GR00T N1, 2024–25）：VLM 骨干 + 流匹配动作专家 + 动作分块是当前最优配方</a:t>
+            </a:r>
+          </a:p>
+        </p:txBody>
+      </p:sp>
+      <p:sp>
+        <p:nvSpPr>
+          <p:cNvPr id="8" name="Rounded Rectangle 7"/>
+          <p:cNvSpPr/>
+          <p:nvPr/>
+        </p:nvSpPr>
+        <p:spPr>
+          <a:xfrm>
+            <a:off x="457200" y="2331720"/>
+            <a:ext cx="11247120" cy="1005840"/>
+          </a:xfrm>
+          <a:prstGeom prst="roundRect">
+            <a:avLst/>
+          </a:prstGeom>
+          <a:solidFill>
+            <a:srgbClr val="FFFFFF"/>
+          </a:solidFill>
+          <a:ln w="12700">
+            <a:solidFill>
+              <a:srgbClr val="1D4ED8"/>
+            </a:solidFill>
+          </a:ln>
+          <a:effectLst/>
+        </p:spPr>
+        <p:style>
+          <a:lnRef idx="1">
+            <a:schemeClr val="accent1"/>
+          </a:lnRef>
+          <a:fillRef idx="3">
+            <a:schemeClr val="accent1"/>
+          </a:fillRef>
+          <a:effectRef idx="2">
+            <a:schemeClr val="accent1"/>
+          </a:effectRef>
+          <a:fontRef idx="minor">
+            <a:schemeClr val="lt1"/>
+          </a:fontRef>
+        </p:style>
+        <p:txBody>
+          <a:bodyPr rtlCol="0" anchor="ctr"/>
+          <a:lstStyle/>
+          <a:p>
+            <a:pPr algn="ctr"/>
+          </a:p>
+        </p:txBody>
+      </p:sp>
+      <p:sp>
+        <p:nvSpPr>
+          <p:cNvPr id="9" name="TextBox 8"/>
+          <p:cNvSpPr txBox="1"/>
+          <p:nvPr/>
+        </p:nvSpPr>
+        <p:spPr>
+          <a:xfrm>
+            <a:off x="685800" y="2404872"/>
+            <a:ext cx="10881360" cy="411480"/>
+          </a:xfrm>
+          <a:prstGeom prst="rect">
+            <a:avLst/>
+          </a:prstGeom>
+          <a:noFill/>
+        </p:spPr>
+        <p:txBody>
+          <a:bodyPr wrap="square" anchor="t" lIns="50800" rIns="50800">
+            <a:spAutoFit/>
+          </a:bodyPr>
+          <a:lstStyle/>
+          <a:p>
+            <a:pPr algn="l">
+              <a:spcAft>
+                <a:spcPts val="400"/>
+              </a:spcAft>
+            </a:pPr>
+            <a:r>
+              <a:rPr sz="1450" b="1">
+                <a:solidFill>
+                  <a:srgbClr val="102A43"/>
+                </a:solidFill>
+                <a:latin typeface="Noto Sans CJK SC"/>
+                <a:ea typeface="Noto Sans CJK SC"/>
+              </a:rPr>
+              <a:t>2. 四个项目的互补启示</a:t>
+            </a:r>
+          </a:p>
+        </p:txBody>
+      </p:sp>
+      <p:sp>
+        <p:nvSpPr>
+          <p:cNvPr id="10" name="TextBox 9"/>
+          <p:cNvSpPr txBox="1"/>
+          <p:nvPr/>
+        </p:nvSpPr>
+        <p:spPr>
+          <a:xfrm>
+            <a:off x="685800" y="2788920"/>
+            <a:ext cx="10881360" cy="502920"/>
+          </a:xfrm>
+          <a:prstGeom prst="rect">
+            <a:avLst/>
+          </a:prstGeom>
+          <a:noFill/>
+        </p:spPr>
+        <p:txBody>
+          <a:bodyPr wrap="square" anchor="t" lIns="50800" rIns="50800">
+            <a:spAutoFit/>
+          </a:bodyPr>
+          <a:lstStyle/>
+          <a:p>
+            <a:pPr algn="l">
+              <a:spcAft>
+                <a:spcPts val="400"/>
+              </a:spcAft>
+            </a:pPr>
+            <a:r>
+              <a:rPr sz="1150" b="0">
+                <a:solidFill>
+                  <a:srgbClr val="475467"/>
+                </a:solidFill>
+                <a:latin typeface="Noto Sans CJK SC"/>
+                <a:ea typeface="Noto Sans CJK SC"/>
+              </a:rPr>
+              <a:t>RT 系证明规模与语义涌现；ACT 提供高频精细控制与低成本数据采集范式；π0 给出通用基座+微调的完整工程栈；GR00T 展示数据金字塔与全栈生态打法</a:t>
+            </a:r>
+          </a:p>
+        </p:txBody>
+      </p:sp>
+      <p:sp>
+        <p:nvSpPr>
+          <p:cNvPr id="11" name="Rounded Rectangle 10"/>
+          <p:cNvSpPr/>
+          <p:nvPr/>
+        </p:nvSpPr>
+        <p:spPr>
+          <a:xfrm>
+            <a:off x="457200" y="3474720"/>
+            <a:ext cx="11247120" cy="1005840"/>
+          </a:xfrm>
+          <a:prstGeom prst="roundRect">
+            <a:avLst/>
+          </a:prstGeom>
+          <a:solidFill>
+            <a:srgbClr val="EFF6FF"/>
+          </a:solidFill>
+          <a:ln w="12700">
+            <a:solidFill>
+              <a:srgbClr val="1D4ED8"/>
+            </a:solidFill>
+          </a:ln>
+          <a:effectLst/>
+        </p:spPr>
+        <p:style>
+          <a:lnRef idx="1">
+            <a:schemeClr val="accent1"/>
+          </a:lnRef>
+          <a:fillRef idx="3">
+            <a:schemeClr val="accent1"/>
+          </a:fillRef>
+          <a:effectRef idx="2">
+            <a:schemeClr val="accent1"/>
+          </a:effectRef>
+          <a:fontRef idx="minor">
+            <a:schemeClr val="lt1"/>
+          </a:fontRef>
+        </p:style>
+        <p:txBody>
+          <a:bodyPr rtlCol="0" anchor="ctr"/>
+          <a:lstStyle/>
+          <a:p>
+            <a:pPr algn="ctr"/>
+          </a:p>
+        </p:txBody>
+      </p:sp>
+      <p:sp>
+        <p:nvSpPr>
+          <p:cNvPr id="12" name="TextBox 11"/>
+          <p:cNvSpPr txBox="1"/>
+          <p:nvPr/>
+        </p:nvSpPr>
+        <p:spPr>
+          <a:xfrm>
+            <a:off x="685800" y="3547872"/>
+            <a:ext cx="10881360" cy="411480"/>
+          </a:xfrm>
+          <a:prstGeom prst="rect">
+            <a:avLst/>
+          </a:prstGeom>
+          <a:noFill/>
+        </p:spPr>
+        <p:txBody>
+          <a:bodyPr wrap="square" anchor="t" lIns="50800" rIns="50800">
+            <a:spAutoFit/>
+          </a:bodyPr>
+          <a:lstStyle/>
+          <a:p>
+            <a:pPr algn="l">
+              <a:spcAft>
+                <a:spcPts val="400"/>
+              </a:spcAft>
+            </a:pPr>
+            <a:r>
+              <a:rPr sz="1450" b="1">
+                <a:solidFill>
+                  <a:srgbClr val="102A43"/>
+                </a:solidFill>
+                <a:latin typeface="Noto Sans CJK SC"/>
+                <a:ea typeface="Noto Sans CJK SC"/>
+              </a:rPr>
+              <a:t>3. 工程主线</a:t>
+            </a:r>
+          </a:p>
+        </p:txBody>
+      </p:sp>
+      <p:sp>
+        <p:nvSpPr>
+          <p:cNvPr id="13" name="TextBox 12"/>
+          <p:cNvSpPr txBox="1"/>
+          <p:nvPr/>
+        </p:nvSpPr>
+        <p:spPr>
+          <a:xfrm>
+            <a:off x="685800" y="3931920"/>
+            <a:ext cx="10881360" cy="502920"/>
+          </a:xfrm>
+          <a:prstGeom prst="rect">
+            <a:avLst/>
+          </a:prstGeom>
+          <a:noFill/>
+        </p:spPr>
+        <p:txBody>
+          <a:bodyPr wrap="square" anchor="t" lIns="50800" rIns="50800">
+            <a:spAutoFit/>
+          </a:bodyPr>
+          <a:lstStyle/>
+          <a:p>
+            <a:pPr algn="l">
+              <a:spcAft>
+                <a:spcPts val="400"/>
+              </a:spcAft>
+            </a:pPr>
+            <a:r>
+              <a:rPr sz="1150" b="0">
+                <a:solidFill>
+                  <a:srgbClr val="475467"/>
+                </a:solidFill>
+                <a:latin typeface="Noto Sans CJK SC"/>
+                <a:ea typeface="Noto Sans CJK SC"/>
+              </a:rPr>
+              <a:t>数据工程占 60% 以上工作量；两阶段训练（预训练+后训练）；动作分块摊销推理延迟；三级评测 + 数据飞轮闭环持续迭代</a:t>
+            </a:r>
+          </a:p>
+        </p:txBody>
+      </p:sp>
+      <p:sp>
+        <p:nvSpPr>
+          <p:cNvPr id="14" name="Rounded Rectangle 13"/>
+          <p:cNvSpPr/>
+          <p:nvPr/>
+        </p:nvSpPr>
+        <p:spPr>
+          <a:xfrm>
+            <a:off x="457200" y="4617720"/>
+            <a:ext cx="11247120" cy="1005840"/>
+          </a:xfrm>
+          <a:prstGeom prst="roundRect">
+            <a:avLst/>
+          </a:prstGeom>
+          <a:solidFill>
+            <a:srgbClr val="FFFFFF"/>
+          </a:solidFill>
+          <a:ln w="12700">
+            <a:solidFill>
+              <a:srgbClr val="1D4ED8"/>
+            </a:solidFill>
+          </a:ln>
+          <a:effectLst/>
+        </p:spPr>
+        <p:style>
+          <a:lnRef idx="1">
+            <a:schemeClr val="accent1"/>
+          </a:lnRef>
+          <a:fillRef idx="3">
+            <a:schemeClr val="accent1"/>
+          </a:fillRef>
+          <a:effectRef idx="2">
+            <a:schemeClr val="accent1"/>
+          </a:effectRef>
+          <a:fontRef idx="minor">
+            <a:schemeClr val="lt1"/>
+          </a:fontRef>
+        </p:style>
+        <p:txBody>
+          <a:bodyPr rtlCol="0" anchor="ctr"/>
+          <a:lstStyle/>
+          <a:p>
+            <a:pPr algn="ctr"/>
+          </a:p>
+        </p:txBody>
+      </p:sp>
+      <p:sp>
+        <p:nvSpPr>
+          <p:cNvPr id="15" name="TextBox 14"/>
+          <p:cNvSpPr txBox="1"/>
+          <p:nvPr/>
+        </p:nvSpPr>
+        <p:spPr>
+          <a:xfrm>
+            <a:off x="685800" y="4690872"/>
+            <a:ext cx="10881360" cy="411480"/>
+          </a:xfrm>
+          <a:prstGeom prst="rect">
+            <a:avLst/>
+          </a:prstGeom>
+          <a:noFill/>
+        </p:spPr>
+        <p:txBody>
+          <a:bodyPr wrap="square" anchor="t" lIns="50800" rIns="50800">
+            <a:spAutoFit/>
+          </a:bodyPr>
+          <a:lstStyle/>
+          <a:p>
+            <a:pPr algn="l">
+              <a:spcAft>
+                <a:spcPts val="400"/>
+              </a:spcAft>
+            </a:pPr>
+            <a:r>
+              <a:rPr sz="1450" b="1">
+                <a:solidFill>
+                  <a:srgbClr val="102A43"/>
+                </a:solidFill>
+                <a:latin typeface="Noto Sans CJK SC"/>
+                <a:ea typeface="Noto Sans CJK SC"/>
+              </a:rPr>
+              <a:t>4. 理性判断</a:t>
+            </a:r>
+          </a:p>
+        </p:txBody>
+      </p:sp>
+      <p:sp>
+        <p:nvSpPr>
+          <p:cNvPr id="16" name="TextBox 15"/>
+          <p:cNvSpPr txBox="1"/>
+          <p:nvPr/>
+        </p:nvSpPr>
+        <p:spPr>
+          <a:xfrm>
+            <a:off x="685800" y="5074920"/>
+            <a:ext cx="10881360" cy="502920"/>
+          </a:xfrm>
+          <a:prstGeom prst="rect">
+            <a:avLst/>
+          </a:prstGeom>
+          <a:noFill/>
+        </p:spPr>
+        <p:txBody>
+          <a:bodyPr wrap="square" anchor="t" lIns="50800" rIns="50800">
+            <a:spAutoFit/>
+          </a:bodyPr>
+          <a:lstStyle/>
+          <a:p>
+            <a:pPr algn="l">
+              <a:spcAft>
+                <a:spcPts val="400"/>
+              </a:spcAft>
+            </a:pPr>
+            <a:r>
+              <a:rPr sz="1150" b="0">
+                <a:solidFill>
+                  <a:srgbClr val="475467"/>
+                </a:solidFill>
+                <a:latin typeface="Noto Sans CJK SC"/>
+                <a:ea typeface="Noto Sans CJK SC"/>
+              </a:rPr>
+              <a:t>VLA 与传统控制是互补而非替代；泛化、安全、实时性仍是落地三大挑战；建议以开源基座（openpi/GR00T）+ 自有场景数据微调作为切入路径</a:t>
+            </a:r>
+          </a:p>
+        </p:txBody>
+      </p:sp>
+      <p:sp>
+        <p:nvSpPr>
+          <p:cNvPr id="17" name="Rounded Rectangle 16"/>
+          <p:cNvSpPr/>
+          <p:nvPr/>
+        </p:nvSpPr>
+        <p:spPr>
+          <a:xfrm>
+            <a:off x="457200" y="5897880"/>
+            <a:ext cx="11247120" cy="594360"/>
+          </a:xfrm>
+          <a:prstGeom prst="roundRect">
+            <a:avLst/>
+          </a:prstGeom>
+          <a:solidFill>
+            <a:srgbClr val="102A43"/>
+          </a:solidFill>
+          <a:ln>
+            <a:noFill/>
+          </a:ln>
+          <a:effectLst/>
+        </p:spPr>
+        <p:style>
+          <a:lnRef idx="1">
+            <a:schemeClr val="accent1"/>
+          </a:lnRef>
+          <a:fillRef idx="3">
+            <a:schemeClr val="accent1"/>
+          </a:fillRef>
+          <a:effectRef idx="2">
+            <a:schemeClr val="accent1"/>
+          </a:effectRef>
+          <a:fontRef idx="minor">
+            <a:schemeClr val="lt1"/>
+          </a:fontRef>
+        </p:style>
+        <p:txBody>
+          <a:bodyPr rtlCol="0" anchor="ctr" wrap="square" lIns="50800" rIns="50800" tIns="25400" bIns="25400"/>
+          <a:lstStyle/>
+          <a:p>
+            <a:pPr algn="ctr"/>
+            <a:r>
+              <a:rPr sz="1200" b="0">
                 <a:solidFill>
                   <a:srgbClr val="93C5FD"/>
                 </a:solidFill>
                 <a:latin typeface="Noto Sans CJK SC"/>
                 <a:ea typeface="Noto Sans CJK SC"/>
               </a:rPr>
-              <a:t>VLA 大模型技术分享报告 · 具身智能技术组</a:t>
+              <a:t>参考项目：github.com/MarkFzp/act-plus-plus · NVIDIA/Isaac-GR00T · Physical-Intelligence/openpi · google-research/robotics_transformer</a:t>
+            </a:r>
+          </a:p>
+        </p:txBody>
+      </p:sp>
+      <p:sp>
+        <p:nvSpPr>
+          <p:cNvPr id="18" name="TextBox 17"/>
+          <p:cNvSpPr txBox="1"/>
+          <p:nvPr/>
+        </p:nvSpPr>
+        <p:spPr>
+          <a:xfrm>
+            <a:off x="11094415" y="6446520"/>
+            <a:ext cx="914400" cy="320040"/>
+          </a:xfrm>
+          <a:prstGeom prst="rect">
+            <a:avLst/>
+          </a:prstGeom>
+          <a:noFill/>
+        </p:spPr>
+        <p:txBody>
+          <a:bodyPr wrap="square" anchor="t" lIns="50800" rIns="50800">
+            <a:spAutoFit/>
+          </a:bodyPr>
+          <a:lstStyle/>
+          <a:p>
+            <a:pPr algn="r">
+              <a:spcAft>
+                <a:spcPts val="400"/>
+              </a:spcAft>
+            </a:pPr>
+            <a:r>
+              <a:rPr sz="1100" b="0">
+                <a:solidFill>
+                  <a:srgbClr val="475467"/>
+                </a:solidFill>
+                <a:latin typeface="Noto Sans CJK SC"/>
+                <a:ea typeface="Noto Sans CJK SC"/>
+              </a:rPr>
+              <a:t>27</a:t>
+            </a:r>
+          </a:p>
+        </p:txBody>
+      </p:sp>
+      <p:sp>
+        <p:nvSpPr>
+          <p:cNvPr id="19" name="TextBox 18"/>
+          <p:cNvSpPr txBox="1"/>
+          <p:nvPr/>
+        </p:nvSpPr>
+        <p:spPr>
+          <a:xfrm>
+            <a:off x="365760" y="6446520"/>
+            <a:ext cx="5486400" cy="320040"/>
+          </a:xfrm>
+          <a:prstGeom prst="rect">
+            <a:avLst/>
+          </a:prstGeom>
+          <a:noFill/>
+        </p:spPr>
+        <p:txBody>
+          <a:bodyPr wrap="square" anchor="t" lIns="50800" rIns="50800">
+            <a:spAutoFit/>
+          </a:bodyPr>
+          <a:lstStyle/>
+          <a:p>
+            <a:pPr algn="l">
+              <a:spcAft>
+                <a:spcPts val="400"/>
+              </a:spcAft>
+            </a:pPr>
+            <a:r>
+              <a:rPr sz="1000" b="0">
+                <a:solidFill>
+                  <a:srgbClr val="475467"/>
+                </a:solidFill>
+                <a:latin typeface="Noto Sans CJK SC"/>
+                <a:ea typeface="Noto Sans CJK SC"/>
+              </a:rPr>
+              <a:t>VLA 大模型技术分享报告</a:t>
             </a:r>
           </a:p>
         </p:txBody>
@@ -19303,7 +19517,7 @@
         <p:spPr>
           <a:xfrm>
             <a:off x="0" y="0"/>
-            <a:ext cx="12191695" cy="868680"/>
+            <a:ext cx="12191695" cy="6858000"/>
           </a:xfrm>
           <a:prstGeom prst="rect">
             <a:avLst/>
@@ -19346,8 +19560,8 @@
         </p:nvSpPr>
         <p:spPr>
           <a:xfrm>
-            <a:off x="0" y="0"/>
-            <a:ext cx="164592" cy="868680"/>
+            <a:off x="0" y="3108960"/>
+            <a:ext cx="12191695" cy="54864"/>
           </a:xfrm>
           <a:prstGeom prst="rect">
             <a:avLst/>
@@ -19390,8 +19604,8 @@
         </p:nvSpPr>
         <p:spPr>
           <a:xfrm>
-            <a:off x="411480" y="73152"/>
-            <a:ext cx="10515600" cy="731520"/>
+            <a:off x="0" y="2286000"/>
+            <a:ext cx="12191695" cy="914400"/>
           </a:xfrm>
           <a:prstGeom prst="rect">
             <a:avLst/>
@@ -19399,69 +19613,107 @@
           <a:noFill/>
         </p:spPr>
         <p:txBody>
-          <a:bodyPr wrap="square" anchor="ctr" lIns="50800" rIns="50800">
+          <a:bodyPr wrap="square" anchor="t" lIns="50800" rIns="50800">
             <a:spAutoFit/>
           </a:bodyPr>
           <a:lstStyle/>
           <a:p>
-            <a:pPr algn="l">
-              <a:spcAft>
-                <a:spcPts val="400"/>
-              </a:spcAft>
-            </a:pPr>
-            <a:r>
-              <a:rPr sz="1200" b="1">
-                <a:solidFill>
-                  <a:srgbClr val="0891B2"/>
-                </a:solidFill>
-                <a:latin typeface="Noto Sans CJK SC"/>
-                <a:ea typeface="Noto Sans CJK SC"/>
-              </a:rPr>
-              <a:t>PART 05 · 发展趋势</a:t>
-            </a:r>
-          </a:p>
-          <a:p>
-            <a:pPr algn="l">
-              <a:spcAft>
-                <a:spcPts val="400"/>
-              </a:spcAft>
-            </a:pPr>
-            <a:r>
-              <a:rPr sz="2400" b="1">
+            <a:pPr algn="ctr">
+              <a:spcAft>
+                <a:spcPts val="400"/>
+              </a:spcAft>
+            </a:pPr>
+            <a:r>
+              <a:rPr sz="4400" b="1">
                 <a:solidFill>
                   <a:srgbClr val="FFFFFF"/>
                 </a:solidFill>
                 <a:latin typeface="Noto Sans CJK SC"/>
                 <a:ea typeface="Noto Sans CJK SC"/>
               </a:rPr>
-              <a:t>VLA 发展趋势总览图</a:t>
-            </a:r>
-          </a:p>
-        </p:txBody>
-      </p:sp>
-      <p:sp>
-        <p:nvSpPr>
-          <p:cNvPr id="5" name="Rounded Rectangle 4"/>
+              <a:t>谢 谢 · Q &amp; A</a:t>
+            </a:r>
+          </a:p>
+        </p:txBody>
+      </p:sp>
+      <p:sp>
+        <p:nvSpPr>
+          <p:cNvPr id="5" name="TextBox 4"/>
+          <p:cNvSpPr txBox="1"/>
+          <p:nvPr/>
+        </p:nvSpPr>
+        <p:spPr>
+          <a:xfrm>
+            <a:off x="0" y="3383280"/>
+            <a:ext cx="12191695" cy="548640"/>
+          </a:xfrm>
+          <a:prstGeom prst="rect">
+            <a:avLst/>
+          </a:prstGeom>
+          <a:noFill/>
+        </p:spPr>
+        <p:txBody>
+          <a:bodyPr wrap="square" anchor="t" lIns="50800" rIns="50800">
+            <a:spAutoFit/>
+          </a:bodyPr>
+          <a:lstStyle/>
+          <a:p>
+            <a:pPr algn="ctr">
+              <a:spcAft>
+                <a:spcPts val="400"/>
+              </a:spcAft>
+            </a:pPr>
+            <a:r>
+              <a:rPr sz="1600" b="0">
+                <a:solidFill>
+                  <a:srgbClr val="93C5FD"/>
+                </a:solidFill>
+                <a:latin typeface="Noto Sans CJK SC"/>
+                <a:ea typeface="Noto Sans CJK SC"/>
+              </a:rPr>
+              <a:t>VLA 大模型技术分享报告 · 具身智能技术组</a:t>
+            </a:r>
+          </a:p>
+        </p:txBody>
+      </p:sp>
+    </p:spTree>
+  </p:cSld>
+  <p:clrMapOvr>
+    <a:masterClrMapping/>
+  </p:clrMapOvr>
+</p:sld>
+</file>
+
+<file path=ppt/slides/slide28.xml><?xml version="1.0" encoding="utf-8"?>
+<p:sld xmlns:a="http://schemas.openxmlformats.org/drawingml/2006/main" xmlns:p="http://schemas.openxmlformats.org/presentationml/2006/main" xmlns:r="http://schemas.openxmlformats.org/officeDocument/2006/relationships">
+  <p:cSld>
+    <p:spTree>
+      <p:nvGrpSpPr>
+        <p:cNvPr id="1" name=""/>
+        <p:cNvGrpSpPr/>
+        <p:nvPr/>
+      </p:nvGrpSpPr>
+      <p:grpSpPr/>
+      <p:sp>
+        <p:nvSpPr>
+          <p:cNvPr id="2" name="Rectangle 1"/>
           <p:cNvSpPr/>
           <p:nvPr/>
         </p:nvSpPr>
         <p:spPr>
           <a:xfrm>
-            <a:off x="3340261" y="987552"/>
-            <a:ext cx="5511172" cy="5111496"/>
-          </a:xfrm>
-          <a:prstGeom prst="roundRect">
+            <a:off x="0" y="0"/>
+            <a:ext cx="12191695" cy="868680"/>
+          </a:xfrm>
+          <a:prstGeom prst="rect">
             <a:avLst/>
           </a:prstGeom>
           <a:solidFill>
-            <a:srgbClr val="FFFFFF"/>
+            <a:srgbClr val="102A43"/>
           </a:solidFill>
-          <a:ln w="12700">
-            <a:solidFill>
-              <a:srgbClr val="D0D5DD"/>
-            </a:solidFill>
+          <a:ln>
+            <a:noFill/>
           </a:ln>
-          <a:effectLst/>
         </p:spPr>
         <p:style>
           <a:lnRef idx="1">
@@ -19485,53 +19737,26 @@
           </a:p>
         </p:txBody>
       </p:sp>
-      <p:pic>
-        <p:nvPicPr>
-          <p:cNvPr id="6" name="Picture 5" descr="VLA发展趋势.png"/>
-          <p:cNvPicPr>
-            <a:picLocks noChangeAspect="1"/>
-          </p:cNvPicPr>
-          <p:nvPr/>
-        </p:nvPicPr>
-        <p:blipFill>
-          <a:blip r:embed="rId2"/>
-          <a:stretch>
-            <a:fillRect/>
-          </a:stretch>
-        </p:blipFill>
-        <p:spPr>
-          <a:xfrm>
-            <a:off x="3449989" y="1097280"/>
-            <a:ext cx="5291716" cy="4892040"/>
-          </a:xfrm>
-          <a:prstGeom prst="rect">
-            <a:avLst/>
-          </a:prstGeom>
-        </p:spPr>
-      </p:pic>
-      <p:sp>
-        <p:nvSpPr>
-          <p:cNvPr id="7" name="Rounded Rectangle 6"/>
+      <p:sp>
+        <p:nvSpPr>
+          <p:cNvPr id="3" name="Rectangle 2"/>
           <p:cNvSpPr/>
           <p:nvPr/>
         </p:nvSpPr>
         <p:spPr>
           <a:xfrm>
-            <a:off x="457200" y="6172200"/>
-            <a:ext cx="11247120" cy="502920"/>
-          </a:xfrm>
-          <a:prstGeom prst="roundRect">
+            <a:off x="0" y="0"/>
+            <a:ext cx="164592" cy="868680"/>
+          </a:xfrm>
+          <a:prstGeom prst="rect">
             <a:avLst/>
           </a:prstGeom>
           <a:solidFill>
-            <a:srgbClr val="EFF6FF"/>
+            <a:srgbClr val="0891B2"/>
           </a:solidFill>
-          <a:ln w="12700">
-            <a:solidFill>
-              <a:srgbClr val="1D4ED8"/>
-            </a:solidFill>
+          <a:ln>
+            <a:noFill/>
           </a:ln>
-          <a:effectLst/>
         </p:spPr>
         <p:style>
           <a:lnRef idx="1">
@@ -19557,14 +19782,182 @@
       </p:sp>
       <p:sp>
         <p:nvSpPr>
+          <p:cNvPr id="4" name="TextBox 3"/>
+          <p:cNvSpPr txBox="1"/>
+          <p:nvPr/>
+        </p:nvSpPr>
+        <p:spPr>
+          <a:xfrm>
+            <a:off x="411480" y="73152"/>
+            <a:ext cx="10515600" cy="731520"/>
+          </a:xfrm>
+          <a:prstGeom prst="rect">
+            <a:avLst/>
+          </a:prstGeom>
+          <a:noFill/>
+        </p:spPr>
+        <p:txBody>
+          <a:bodyPr wrap="square">
+            <a:spAutoFit/>
+          </a:bodyPr>
+          <a:lstStyle/>
+          <a:p>
+            <a:r>
+              <a:rPr sz="1200" b="1">
+                <a:solidFill>
+                  <a:srgbClr val="0891B2"/>
+                </a:solidFill>
+                <a:latin typeface="Noto Sans CJK SC"/>
+                <a:ea typeface="Noto Sans CJK SC"/>
+              </a:rPr>
+              <a:t>PART 05 · 行业洞察</a:t>
+            </a:r>
+          </a:p>
+          <a:p>
+            <a:r>
+              <a:rPr sz="2400" b="1">
+                <a:solidFill>
+                  <a:srgbClr val="FFFFFF"/>
+                </a:solidFill>
+                <a:latin typeface="Noto Sans CJK SC"/>
+                <a:ea typeface="Noto Sans CJK SC"/>
+              </a:rPr>
+              <a:t>WAIC 具身智能圆桌论坛纪要：三道物理墙与产业路线之争</a:t>
+            </a:r>
+          </a:p>
+        </p:txBody>
+      </p:sp>
+      <p:sp>
+        <p:nvSpPr>
+          <p:cNvPr id="5" name="Rounded Rectangle 4"/>
+          <p:cNvSpPr/>
+          <p:nvPr/>
+        </p:nvSpPr>
+        <p:spPr>
+          <a:xfrm>
+            <a:off x="457200" y="1143000"/>
+            <a:ext cx="11247120" cy="914400"/>
+          </a:xfrm>
+          <a:prstGeom prst="roundRect">
+            <a:avLst/>
+          </a:prstGeom>
+          <a:solidFill>
+            <a:srgbClr val="FFFFFF"/>
+          </a:solidFill>
+          <a:ln>
+            <a:noFill/>
+          </a:ln>
+        </p:spPr>
+        <p:style>
+          <a:lnRef idx="1">
+            <a:schemeClr val="accent1"/>
+          </a:lnRef>
+          <a:fillRef idx="3">
+            <a:schemeClr val="accent1"/>
+          </a:fillRef>
+          <a:effectRef idx="2">
+            <a:schemeClr val="accent1"/>
+          </a:effectRef>
+          <a:fontRef idx="minor">
+            <a:schemeClr val="lt1"/>
+          </a:fontRef>
+        </p:style>
+        <p:txBody>
+          <a:bodyPr rtlCol="0" anchor="ctr"/>
+          <a:lstStyle/>
+          <a:p>
+            <a:pPr algn="ctr"/>
+          </a:p>
+        </p:txBody>
+      </p:sp>
+      <p:sp>
+        <p:nvSpPr>
+          <p:cNvPr id="6" name="Rectangle 5"/>
+          <p:cNvSpPr/>
+          <p:nvPr/>
+        </p:nvSpPr>
+        <p:spPr>
+          <a:xfrm>
+            <a:off x="457200" y="1143000"/>
+            <a:ext cx="118872" cy="914400"/>
+          </a:xfrm>
+          <a:prstGeom prst="rect">
+            <a:avLst/>
+          </a:prstGeom>
+          <a:solidFill>
+            <a:srgbClr val="1D4ED8"/>
+          </a:solidFill>
+          <a:ln>
+            <a:noFill/>
+          </a:ln>
+        </p:spPr>
+        <p:style>
+          <a:lnRef idx="1">
+            <a:schemeClr val="accent1"/>
+          </a:lnRef>
+          <a:fillRef idx="3">
+            <a:schemeClr val="accent1"/>
+          </a:fillRef>
+          <a:effectRef idx="2">
+            <a:schemeClr val="accent1"/>
+          </a:effectRef>
+          <a:fontRef idx="minor">
+            <a:schemeClr val="lt1"/>
+          </a:fontRef>
+        </p:style>
+        <p:txBody>
+          <a:bodyPr rtlCol="0" anchor="ctr"/>
+          <a:lstStyle/>
+          <a:p>
+            <a:pPr algn="ctr"/>
+          </a:p>
+        </p:txBody>
+      </p:sp>
+      <p:sp>
+        <p:nvSpPr>
+          <p:cNvPr id="7" name="TextBox 6"/>
+          <p:cNvSpPr txBox="1"/>
+          <p:nvPr/>
+        </p:nvSpPr>
+        <p:spPr>
+          <a:xfrm>
+            <a:off x="731520" y="1197864"/>
+            <a:ext cx="10881360" cy="384048"/>
+          </a:xfrm>
+          <a:prstGeom prst="rect">
+            <a:avLst/>
+          </a:prstGeom>
+          <a:noFill/>
+        </p:spPr>
+        <p:txBody>
+          <a:bodyPr wrap="square">
+            <a:spAutoFit/>
+          </a:bodyPr>
+          <a:lstStyle/>
+          <a:p>
+            <a:r>
+              <a:rPr sz="1350" b="1">
+                <a:solidFill>
+                  <a:srgbClr val="1D4ED8"/>
+                </a:solidFill>
+                <a:latin typeface="Noto Sans CJK SC"/>
+                <a:ea typeface="Noto Sans CJK SC"/>
+              </a:rPr>
+              <a:t>① 三道物理墙：具身智能规模化的核心阻碍（全场共识）</a:t>
+            </a:r>
+          </a:p>
+        </p:txBody>
+      </p:sp>
+      <p:sp>
+        <p:nvSpPr>
           <p:cNvPr id="8" name="TextBox 7"/>
           <p:cNvSpPr txBox="1"/>
           <p:nvPr/>
         </p:nvSpPr>
         <p:spPr>
           <a:xfrm>
-            <a:off x="685800" y="6172200"/>
-            <a:ext cx="10881360" cy="502920"/>
+            <a:off x="731520" y="1563624"/>
+            <a:ext cx="10881360" cy="457200"/>
           </a:xfrm>
           <a:prstGeom prst="rect">
             <a:avLst/>
@@ -19572,32 +19965,686 @@
           <a:noFill/>
         </p:spPr>
         <p:txBody>
-          <a:bodyPr wrap="square" anchor="ctr" lIns="50800" rIns="50800">
+          <a:bodyPr wrap="square">
             <a:spAutoFit/>
           </a:bodyPr>
           <a:lstStyle/>
           <a:p>
-            <a:pPr algn="l">
-              <a:spcAft>
-                <a:spcPts val="400"/>
-              </a:spcAft>
-            </a:pPr>
-            <a:r>
-              <a:rPr sz="1200" b="1">
-                <a:solidFill>
-                  <a:srgbClr val="102A43"/>
-                </a:solidFill>
-                <a:latin typeface="Noto Sans CJK SC"/>
-                <a:ea typeface="Noto Sans CJK SC"/>
-              </a:rPr>
-              <a:t>图：VLA 发展趋势总览（来源：reports/VLA发展趋势.png）</a:t>
-            </a:r>
-          </a:p>
-        </p:txBody>
-      </p:sp>
-      <p:sp>
-        <p:nvSpPr>
-          <p:cNvPr id="9" name="TextBox 8"/>
+            <a:r>
+              <a:rPr sz="1000" b="0">
+                <a:solidFill>
+                  <a:srgbClr val="475467"/>
+                </a:solidFill>
+                <a:latin typeface="Noto Sans CJK SC"/>
+                <a:ea typeface="Noto Sans CJK SC"/>
+              </a:rPr>
+              <a:t>数据墙：真机交互数据成本高、无法批量爬取；表征墙：机型数据不互通、缺少通用物理表征、跨设备泛化差；闭环墙：实体试错成本高、反馈慢、数据飞轮难以快速迭代——无法复刻 LLM 的 scaling 路径，需以世界模型仿真 + 多机集群采集 + 数据回流闭环统一破局</a:t>
+            </a:r>
+          </a:p>
+        </p:txBody>
+      </p:sp>
+      <p:sp>
+        <p:nvSpPr>
+          <p:cNvPr id="9" name="Rounded Rectangle 8"/>
+          <p:cNvSpPr/>
+          <p:nvPr/>
+        </p:nvSpPr>
+        <p:spPr>
+          <a:xfrm>
+            <a:off x="457200" y="2176272"/>
+            <a:ext cx="11247120" cy="914400"/>
+          </a:xfrm>
+          <a:prstGeom prst="roundRect">
+            <a:avLst/>
+          </a:prstGeom>
+          <a:solidFill>
+            <a:srgbClr val="FFFFFF"/>
+          </a:solidFill>
+          <a:ln>
+            <a:noFill/>
+          </a:ln>
+        </p:spPr>
+        <p:style>
+          <a:lnRef idx="1">
+            <a:schemeClr val="accent1"/>
+          </a:lnRef>
+          <a:fillRef idx="3">
+            <a:schemeClr val="accent1"/>
+          </a:fillRef>
+          <a:effectRef idx="2">
+            <a:schemeClr val="accent1"/>
+          </a:effectRef>
+          <a:fontRef idx="minor">
+            <a:schemeClr val="lt1"/>
+          </a:fontRef>
+        </p:style>
+        <p:txBody>
+          <a:bodyPr rtlCol="0" anchor="ctr"/>
+          <a:lstStyle/>
+          <a:p>
+            <a:pPr algn="ctr"/>
+          </a:p>
+        </p:txBody>
+      </p:sp>
+      <p:sp>
+        <p:nvSpPr>
+          <p:cNvPr id="10" name="Rectangle 9"/>
+          <p:cNvSpPr/>
+          <p:nvPr/>
+        </p:nvSpPr>
+        <p:spPr>
+          <a:xfrm>
+            <a:off x="457200" y="2176272"/>
+            <a:ext cx="118872" cy="914400"/>
+          </a:xfrm>
+          <a:prstGeom prst="rect">
+            <a:avLst/>
+          </a:prstGeom>
+          <a:solidFill>
+            <a:srgbClr val="1D4ED8"/>
+          </a:solidFill>
+          <a:ln>
+            <a:noFill/>
+          </a:ln>
+        </p:spPr>
+        <p:style>
+          <a:lnRef idx="1">
+            <a:schemeClr val="accent1"/>
+          </a:lnRef>
+          <a:fillRef idx="3">
+            <a:schemeClr val="accent1"/>
+          </a:fillRef>
+          <a:effectRef idx="2">
+            <a:schemeClr val="accent1"/>
+          </a:effectRef>
+          <a:fontRef idx="minor">
+            <a:schemeClr val="lt1"/>
+          </a:fontRef>
+        </p:style>
+        <p:txBody>
+          <a:bodyPr rtlCol="0" anchor="ctr"/>
+          <a:lstStyle/>
+          <a:p>
+            <a:pPr algn="ctr"/>
+          </a:p>
+        </p:txBody>
+      </p:sp>
+      <p:sp>
+        <p:nvSpPr>
+          <p:cNvPr id="11" name="TextBox 10"/>
+          <p:cNvSpPr txBox="1"/>
+          <p:nvPr/>
+        </p:nvSpPr>
+        <p:spPr>
+          <a:xfrm>
+            <a:off x="731520" y="2231136"/>
+            <a:ext cx="10881360" cy="384048"/>
+          </a:xfrm>
+          <a:prstGeom prst="rect">
+            <a:avLst/>
+          </a:prstGeom>
+          <a:noFill/>
+        </p:spPr>
+        <p:txBody>
+          <a:bodyPr wrap="square">
+            <a:spAutoFit/>
+          </a:bodyPr>
+          <a:lstStyle/>
+          <a:p>
+            <a:r>
+              <a:rPr sz="1350" b="1">
+                <a:solidFill>
+                  <a:srgbClr val="1D4ED8"/>
+                </a:solidFill>
+                <a:latin typeface="Noto Sans CJK SC"/>
+                <a:ea typeface="Noto Sans CJK SC"/>
+              </a:rPr>
+              <a:t>② 数据获取路径：单一来源不足，多类数据混合成共识</a:t>
+            </a:r>
+          </a:p>
+        </p:txBody>
+      </p:sp>
+      <p:sp>
+        <p:nvSpPr>
+          <p:cNvPr id="12" name="TextBox 11"/>
+          <p:cNvSpPr txBox="1"/>
+          <p:nvPr/>
+        </p:nvSpPr>
+        <p:spPr>
+          <a:xfrm>
+            <a:off x="731520" y="2596896"/>
+            <a:ext cx="10881360" cy="457200"/>
+          </a:xfrm>
+          <a:prstGeom prst="rect">
+            <a:avLst/>
+          </a:prstGeom>
+          <a:noFill/>
+        </p:spPr>
+        <p:txBody>
+          <a:bodyPr wrap="square">
+            <a:spAutoFit/>
+          </a:bodyPr>
+          <a:lstStyle/>
+          <a:p>
+            <a:r>
+              <a:rPr sz="1000" b="0">
+                <a:solidFill>
+                  <a:srgbClr val="475467"/>
+                </a:solidFill>
+                <a:latin typeface="Noto Sans CJK SC"/>
+                <a:ea typeface="Noto Sans CJK SC"/>
+              </a:rPr>
+              <a:t>PI 主打规模化真机采集；佐治亚理工押注人类第一视角 Egocentric 数据（对齐方案尚无标准）；Genesis 用仿生手套低成本采集；Dyna 采用三层金字塔（互联网视频打底 + 真机数据 + 产线失败回流，20 万小时预训练、新任务 1–2 小时微调）；清华主张互联网视频预训练专属具身基座——真实部署回流的失败样本价值最高</a:t>
+            </a:r>
+          </a:p>
+        </p:txBody>
+      </p:sp>
+      <p:sp>
+        <p:nvSpPr>
+          <p:cNvPr id="13" name="Rounded Rectangle 12"/>
+          <p:cNvSpPr/>
+          <p:nvPr/>
+        </p:nvSpPr>
+        <p:spPr>
+          <a:xfrm>
+            <a:off x="457200" y="3209544"/>
+            <a:ext cx="11247120" cy="914400"/>
+          </a:xfrm>
+          <a:prstGeom prst="roundRect">
+            <a:avLst/>
+          </a:prstGeom>
+          <a:solidFill>
+            <a:srgbClr val="FFFFFF"/>
+          </a:solidFill>
+          <a:ln>
+            <a:noFill/>
+          </a:ln>
+        </p:spPr>
+        <p:style>
+          <a:lnRef idx="1">
+            <a:schemeClr val="accent1"/>
+          </a:lnRef>
+          <a:fillRef idx="3">
+            <a:schemeClr val="accent1"/>
+          </a:fillRef>
+          <a:effectRef idx="2">
+            <a:schemeClr val="accent1"/>
+          </a:effectRef>
+          <a:fontRef idx="minor">
+            <a:schemeClr val="lt1"/>
+          </a:fontRef>
+        </p:style>
+        <p:txBody>
+          <a:bodyPr rtlCol="0" anchor="ctr"/>
+          <a:lstStyle/>
+          <a:p>
+            <a:pPr algn="ctr"/>
+          </a:p>
+        </p:txBody>
+      </p:sp>
+      <p:sp>
+        <p:nvSpPr>
+          <p:cNvPr id="14" name="Rectangle 13"/>
+          <p:cNvSpPr/>
+          <p:nvPr/>
+        </p:nvSpPr>
+        <p:spPr>
+          <a:xfrm>
+            <a:off x="457200" y="3209544"/>
+            <a:ext cx="118872" cy="914400"/>
+          </a:xfrm>
+          <a:prstGeom prst="rect">
+            <a:avLst/>
+          </a:prstGeom>
+          <a:solidFill>
+            <a:srgbClr val="1D4ED8"/>
+          </a:solidFill>
+          <a:ln>
+            <a:noFill/>
+          </a:ln>
+        </p:spPr>
+        <p:style>
+          <a:lnRef idx="1">
+            <a:schemeClr val="accent1"/>
+          </a:lnRef>
+          <a:fillRef idx="3">
+            <a:schemeClr val="accent1"/>
+          </a:fillRef>
+          <a:effectRef idx="2">
+            <a:schemeClr val="accent1"/>
+          </a:effectRef>
+          <a:fontRef idx="minor">
+            <a:schemeClr val="lt1"/>
+          </a:fontRef>
+        </p:style>
+        <p:txBody>
+          <a:bodyPr rtlCol="0" anchor="ctr"/>
+          <a:lstStyle/>
+          <a:p>
+            <a:pPr algn="ctr"/>
+          </a:p>
+        </p:txBody>
+      </p:sp>
+      <p:sp>
+        <p:nvSpPr>
+          <p:cNvPr id="15" name="TextBox 14"/>
+          <p:cNvSpPr txBox="1"/>
+          <p:nvPr/>
+        </p:nvSpPr>
+        <p:spPr>
+          <a:xfrm>
+            <a:off x="731520" y="3264408"/>
+            <a:ext cx="10881360" cy="384048"/>
+          </a:xfrm>
+          <a:prstGeom prst="rect">
+            <a:avLst/>
+          </a:prstGeom>
+          <a:noFill/>
+        </p:spPr>
+        <p:txBody>
+          <a:bodyPr wrap="square">
+            <a:spAutoFit/>
+          </a:bodyPr>
+          <a:lstStyle/>
+          <a:p>
+            <a:r>
+              <a:rPr sz="1350" b="1">
+                <a:solidFill>
+                  <a:srgbClr val="1D4ED8"/>
+                </a:solidFill>
+                <a:latin typeface="Noto Sans CJK SC"/>
+                <a:ea typeface="Noto Sans CJK SC"/>
+              </a:rPr>
+              <a:t>③ 模型架构路线：VLA 与世界模型不对立，长期走向融合</a:t>
+            </a:r>
+          </a:p>
+        </p:txBody>
+      </p:sp>
+      <p:sp>
+        <p:nvSpPr>
+          <p:cNvPr id="16" name="TextBox 15"/>
+          <p:cNvSpPr txBox="1"/>
+          <p:nvPr/>
+        </p:nvSpPr>
+        <p:spPr>
+          <a:xfrm>
+            <a:off x="731520" y="3630168"/>
+            <a:ext cx="10881360" cy="457200"/>
+          </a:xfrm>
+          <a:prstGeom prst="rect">
+            <a:avLst/>
+          </a:prstGeom>
+          <a:noFill/>
+        </p:spPr>
+        <p:txBody>
+          <a:bodyPr wrap="square">
+            <a:spAutoFit/>
+          </a:bodyPr>
+          <a:lstStyle/>
+          <a:p>
+            <a:r>
+              <a:rPr sz="1000" b="0">
+                <a:solidFill>
+                  <a:srgbClr val="475467"/>
+                </a:solidFill>
+                <a:latin typeface="Noto Sans CJK SC"/>
+                <a:ea typeface="Noto Sans CJK SC"/>
+              </a:rPr>
+              <a:t>PI：VLA+世界模型融合，生成未来画面提升长程规划；Dyna：WAM 世界动作模型主导高频操作、规划模型负责长周期任务；腾讯：认知规划/感知动作/电机控制三层 Agent 架构；智元：VLA 与世界模型同步迭代，终局为 WRAM + 分布式真机强化学习；评判标准归结为数据学习能力、跨场景泛化与推理速度</a:t>
+            </a:r>
+          </a:p>
+        </p:txBody>
+      </p:sp>
+      <p:sp>
+        <p:nvSpPr>
+          <p:cNvPr id="17" name="Rounded Rectangle 16"/>
+          <p:cNvSpPr/>
+          <p:nvPr/>
+        </p:nvSpPr>
+        <p:spPr>
+          <a:xfrm>
+            <a:off x="457200" y="4242816"/>
+            <a:ext cx="11247120" cy="914400"/>
+          </a:xfrm>
+          <a:prstGeom prst="roundRect">
+            <a:avLst/>
+          </a:prstGeom>
+          <a:solidFill>
+            <a:srgbClr val="FFFFFF"/>
+          </a:solidFill>
+          <a:ln>
+            <a:noFill/>
+          </a:ln>
+        </p:spPr>
+        <p:style>
+          <a:lnRef idx="1">
+            <a:schemeClr val="accent1"/>
+          </a:lnRef>
+          <a:fillRef idx="3">
+            <a:schemeClr val="accent1"/>
+          </a:fillRef>
+          <a:effectRef idx="2">
+            <a:schemeClr val="accent1"/>
+          </a:effectRef>
+          <a:fontRef idx="minor">
+            <a:schemeClr val="lt1"/>
+          </a:fontRef>
+        </p:style>
+        <p:txBody>
+          <a:bodyPr rtlCol="0" anchor="ctr"/>
+          <a:lstStyle/>
+          <a:p>
+            <a:pPr algn="ctr"/>
+          </a:p>
+        </p:txBody>
+      </p:sp>
+      <p:sp>
+        <p:nvSpPr>
+          <p:cNvPr id="18" name="Rectangle 17"/>
+          <p:cNvSpPr/>
+          <p:nvPr/>
+        </p:nvSpPr>
+        <p:spPr>
+          <a:xfrm>
+            <a:off x="457200" y="4242816"/>
+            <a:ext cx="118872" cy="914400"/>
+          </a:xfrm>
+          <a:prstGeom prst="rect">
+            <a:avLst/>
+          </a:prstGeom>
+          <a:solidFill>
+            <a:srgbClr val="1D4ED8"/>
+          </a:solidFill>
+          <a:ln>
+            <a:noFill/>
+          </a:ln>
+        </p:spPr>
+        <p:style>
+          <a:lnRef idx="1">
+            <a:schemeClr val="accent1"/>
+          </a:lnRef>
+          <a:fillRef idx="3">
+            <a:schemeClr val="accent1"/>
+          </a:fillRef>
+          <a:effectRef idx="2">
+            <a:schemeClr val="accent1"/>
+          </a:effectRef>
+          <a:fontRef idx="minor">
+            <a:schemeClr val="lt1"/>
+          </a:fontRef>
+        </p:style>
+        <p:txBody>
+          <a:bodyPr rtlCol="0" anchor="ctr"/>
+          <a:lstStyle/>
+          <a:p>
+            <a:pPr algn="ctr"/>
+          </a:p>
+        </p:txBody>
+      </p:sp>
+      <p:sp>
+        <p:nvSpPr>
+          <p:cNvPr id="19" name="TextBox 18"/>
+          <p:cNvSpPr txBox="1"/>
+          <p:nvPr/>
+        </p:nvSpPr>
+        <p:spPr>
+          <a:xfrm>
+            <a:off x="731520" y="4297679"/>
+            <a:ext cx="10881360" cy="384048"/>
+          </a:xfrm>
+          <a:prstGeom prst="rect">
+            <a:avLst/>
+          </a:prstGeom>
+          <a:noFill/>
+        </p:spPr>
+        <p:txBody>
+          <a:bodyPr wrap="square">
+            <a:spAutoFit/>
+          </a:bodyPr>
+          <a:lstStyle/>
+          <a:p>
+            <a:r>
+              <a:rPr sz="1350" b="1">
+                <a:solidFill>
+                  <a:srgbClr val="1D4ED8"/>
+                </a:solidFill>
+                <a:latin typeface="Noto Sans CJK SC"/>
+                <a:ea typeface="Noto Sans CJK SC"/>
+              </a:rPr>
+              <a:t>④ 企业路线选择：全栈自研 vs 纯 AI 大脑，无优劣之分</a:t>
+            </a:r>
+          </a:p>
+        </p:txBody>
+      </p:sp>
+      <p:sp>
+        <p:nvSpPr>
+          <p:cNvPr id="20" name="TextBox 19"/>
+          <p:cNvSpPr txBox="1"/>
+          <p:nvPr/>
+        </p:nvSpPr>
+        <p:spPr>
+          <a:xfrm>
+            <a:off x="731520" y="4663440"/>
+            <a:ext cx="10881360" cy="457200"/>
+          </a:xfrm>
+          <a:prstGeom prst="rect">
+            <a:avLst/>
+          </a:prstGeom>
+          <a:noFill/>
+        </p:spPr>
+        <p:txBody>
+          <a:bodyPr wrap="square">
+            <a:spAutoFit/>
+          </a:bodyPr>
+          <a:lstStyle/>
+          <a:p>
+            <a:r>
+              <a:rPr sz="1000" b="0">
+                <a:solidFill>
+                  <a:srgbClr val="475467"/>
+                </a:solidFill>
+                <a:latin typeface="Noto Sans CJK SC"/>
+                <a:ea typeface="Noto Sans CJK SC"/>
+              </a:rPr>
+              <a:t>智元走全栈自研（硬件限制模型上限，自研可优化端云协同与量产成本）；PI/腾讯走纯算法路线（先用通用机械臂搭数据底座、避开硬件重资产赛道）；Sunday 折中（低成本夹爪 + 少量硬件实现大部分操作，当前瓶颈在上层 AI 模型而非硬件手爪）</a:t>
+            </a:r>
+          </a:p>
+        </p:txBody>
+      </p:sp>
+      <p:sp>
+        <p:nvSpPr>
+          <p:cNvPr id="21" name="Rounded Rectangle 20"/>
+          <p:cNvSpPr/>
+          <p:nvPr/>
+        </p:nvSpPr>
+        <p:spPr>
+          <a:xfrm>
+            <a:off x="457200" y="5276088"/>
+            <a:ext cx="11247120" cy="914400"/>
+          </a:xfrm>
+          <a:prstGeom prst="roundRect">
+            <a:avLst/>
+          </a:prstGeom>
+          <a:solidFill>
+            <a:srgbClr val="FFFFFF"/>
+          </a:solidFill>
+          <a:ln>
+            <a:noFill/>
+          </a:ln>
+        </p:spPr>
+        <p:style>
+          <a:lnRef idx="1">
+            <a:schemeClr val="accent1"/>
+          </a:lnRef>
+          <a:fillRef idx="3">
+            <a:schemeClr val="accent1"/>
+          </a:fillRef>
+          <a:effectRef idx="2">
+            <a:schemeClr val="accent1"/>
+          </a:effectRef>
+          <a:fontRef idx="minor">
+            <a:schemeClr val="lt1"/>
+          </a:fontRef>
+        </p:style>
+        <p:txBody>
+          <a:bodyPr rtlCol="0" anchor="ctr"/>
+          <a:lstStyle/>
+          <a:p>
+            <a:pPr algn="ctr"/>
+          </a:p>
+        </p:txBody>
+      </p:sp>
+      <p:sp>
+        <p:nvSpPr>
+          <p:cNvPr id="22" name="Rectangle 21"/>
+          <p:cNvSpPr/>
+          <p:nvPr/>
+        </p:nvSpPr>
+        <p:spPr>
+          <a:xfrm>
+            <a:off x="457200" y="5276088"/>
+            <a:ext cx="118872" cy="914400"/>
+          </a:xfrm>
+          <a:prstGeom prst="rect">
+            <a:avLst/>
+          </a:prstGeom>
+          <a:solidFill>
+            <a:srgbClr val="1D4ED8"/>
+          </a:solidFill>
+          <a:ln>
+            <a:noFill/>
+          </a:ln>
+        </p:spPr>
+        <p:style>
+          <a:lnRef idx="1">
+            <a:schemeClr val="accent1"/>
+          </a:lnRef>
+          <a:fillRef idx="3">
+            <a:schemeClr val="accent1"/>
+          </a:fillRef>
+          <a:effectRef idx="2">
+            <a:schemeClr val="accent1"/>
+          </a:effectRef>
+          <a:fontRef idx="minor">
+            <a:schemeClr val="lt1"/>
+          </a:fontRef>
+        </p:style>
+        <p:txBody>
+          <a:bodyPr rtlCol="0" anchor="ctr"/>
+          <a:lstStyle/>
+          <a:p>
+            <a:pPr algn="ctr"/>
+          </a:p>
+        </p:txBody>
+      </p:sp>
+      <p:sp>
+        <p:nvSpPr>
+          <p:cNvPr id="23" name="TextBox 22"/>
+          <p:cNvSpPr txBox="1"/>
+          <p:nvPr/>
+        </p:nvSpPr>
+        <p:spPr>
+          <a:xfrm>
+            <a:off x="731520" y="5330951"/>
+            <a:ext cx="10881360" cy="384048"/>
+          </a:xfrm>
+          <a:prstGeom prst="rect">
+            <a:avLst/>
+          </a:prstGeom>
+          <a:noFill/>
+        </p:spPr>
+        <p:txBody>
+          <a:bodyPr wrap="square">
+            <a:spAutoFit/>
+          </a:bodyPr>
+          <a:lstStyle/>
+          <a:p>
+            <a:r>
+              <a:rPr sz="1350" b="1">
+                <a:solidFill>
+                  <a:srgbClr val="1D4ED8"/>
+                </a:solidFill>
+                <a:latin typeface="Noto Sans CJK SC"/>
+                <a:ea typeface="Noto Sans CJK SC"/>
+              </a:rPr>
+              <a:t>⑤ 对本报告的启示</a:t>
+            </a:r>
+          </a:p>
+        </p:txBody>
+      </p:sp>
+      <p:sp>
+        <p:nvSpPr>
+          <p:cNvPr id="24" name="TextBox 23"/>
+          <p:cNvSpPr txBox="1"/>
+          <p:nvPr/>
+        </p:nvSpPr>
+        <p:spPr>
+          <a:xfrm>
+            <a:off x="731520" y="5696712"/>
+            <a:ext cx="10881360" cy="457200"/>
+          </a:xfrm>
+          <a:prstGeom prst="rect">
+            <a:avLst/>
+          </a:prstGeom>
+          <a:noFill/>
+        </p:spPr>
+        <p:txBody>
+          <a:bodyPr wrap="square">
+            <a:spAutoFit/>
+          </a:bodyPr>
+          <a:lstStyle/>
+          <a:p>
+            <a:r>
+              <a:rPr sz="1000" b="0">
+                <a:solidFill>
+                  <a:srgbClr val="475467"/>
+                </a:solidFill>
+                <a:latin typeface="Noto Sans CJK SC"/>
+                <a:ea typeface="Noto Sans CJK SC"/>
+              </a:rPr>
+              <a:t>论坛结论与前述五大趋势互相印证：数据金字塔与回流闭环（对应趋势①）、分层双系统与世界模型融合（对应趋势②）、统一评测标准缺失（对应趋势④）仍是 VLA 走向规模化落地必须跨越的门槛</a:t>
+            </a:r>
+          </a:p>
+        </p:txBody>
+      </p:sp>
+      <p:sp>
+        <p:nvSpPr>
+          <p:cNvPr id="25" name="TextBox 24"/>
+          <p:cNvSpPr txBox="1"/>
+          <p:nvPr/>
+        </p:nvSpPr>
+        <p:spPr>
+          <a:xfrm>
+            <a:off x="11094415" y="6446520"/>
+            <a:ext cx="914400" cy="320040"/>
+          </a:xfrm>
+          <a:prstGeom prst="rect">
+            <a:avLst/>
+          </a:prstGeom>
+          <a:noFill/>
+        </p:spPr>
+        <p:txBody>
+          <a:bodyPr wrap="square">
+            <a:spAutoFit/>
+          </a:bodyPr>
+          <a:lstStyle/>
+          <a:p>
+            <a:r>
+              <a:rPr sz="1100" b="0">
+                <a:solidFill>
+                  <a:srgbClr val="475467"/>
+                </a:solidFill>
+                <a:latin typeface="Noto Sans CJK SC"/>
+                <a:ea typeface="Noto Sans CJK SC"/>
+              </a:rPr>
+              <a:t>26</a:t>
+            </a:r>
+          </a:p>
+        </p:txBody>
+      </p:sp>
+      <p:sp>
+        <p:nvSpPr>
+          <p:cNvPr id="26" name="TextBox 25"/>
           <p:cNvSpPr txBox="1"/>
           <p:nvPr/>
         </p:nvSpPr>
@@ -19612,16 +20659,11 @@
           <a:noFill/>
         </p:spPr>
         <p:txBody>
-          <a:bodyPr wrap="square" anchor="t" lIns="50800" rIns="50800">
+          <a:bodyPr wrap="square">
             <a:spAutoFit/>
           </a:bodyPr>
           <a:lstStyle/>
           <a:p>
-            <a:pPr algn="l">
-              <a:spcAft>
-                <a:spcPts val="400"/>
-              </a:spcAft>
-            </a:pPr>
             <a:r>
               <a:rPr sz="1000" b="0">
                 <a:solidFill>
@@ -19630,47 +20672,7 @@
                 <a:latin typeface="Noto Sans CJK SC"/>
                 <a:ea typeface="Noto Sans CJK SC"/>
               </a:rPr>
-              <a:t>VLA 大模型技术分享报告</a:t>
-            </a:r>
-          </a:p>
-        </p:txBody>
-      </p:sp>
-      <p:sp>
-        <p:nvSpPr>
-          <p:cNvPr id="10" name="TextBox 9"/>
-          <p:cNvSpPr txBox="1"/>
-          <p:nvPr/>
-        </p:nvSpPr>
-        <p:spPr>
-          <a:xfrm>
-            <a:off x="11094415" y="6446520"/>
-            <a:ext cx="914400" cy="320040"/>
-          </a:xfrm>
-          <a:prstGeom prst="rect">
-            <a:avLst/>
-          </a:prstGeom>
-          <a:noFill/>
-        </p:spPr>
-        <p:txBody>
-          <a:bodyPr wrap="square" anchor="t" lIns="50800" rIns="50800">
-            <a:spAutoFit/>
-          </a:bodyPr>
-          <a:lstStyle/>
-          <a:p>
-            <a:pPr algn="r">
-              <a:spcAft>
-                <a:spcPts val="400"/>
-              </a:spcAft>
-            </a:pPr>
-            <a:r>
-              <a:rPr sz="1100" b="0">
-                <a:solidFill>
-                  <a:srgbClr val="475467"/>
-                </a:solidFill>
-                <a:latin typeface="Noto Sans CJK SC"/>
-                <a:ea typeface="Noto Sans CJK SC"/>
-              </a:rPr>
-              <a:t>25</a:t>
+              <a:t>VLA 大模型技术分享报告 · 内容整合自：具身智能会议.png / 具身智能会议2.png / 具身智能会议3.png</a:t>
             </a:r>
           </a:p>
         </p:txBody>

</xml_diff>

<commit_message>
Add VLA current shortcomings panel to slide 6
</commit_message>
<xml_diff>
--- a/reports/VLA大模型技术分享报告.pptx
+++ b/reports/VLA大模型技术分享报告.pptx
@@ -24867,7 +24867,7 @@
                 <a:latin typeface="Noto Sans CJK SC"/>
                 <a:ea typeface="Noto Sans CJK SC"/>
               </a:rPr>
-              <a:t>VLA 的战略意义与四大核心优势</a:t>
+              <a:t>VLA 的战略意义、四大核心优势与当前不足</a:t>
             </a:r>
           </a:p>
         </p:txBody>
@@ -24880,8 +24880,8 @@
         </p:nvSpPr>
         <p:spPr>
           <a:xfrm>
-            <a:off x="457200" y="1051560"/>
-            <a:ext cx="11247120" cy="502920"/>
+            <a:off x="457200" y="932688"/>
+            <a:ext cx="11247120" cy="457200"/>
           </a:xfrm>
           <a:prstGeom prst="rect">
             <a:avLst/>
@@ -24920,8 +24920,8 @@
         </p:nvSpPr>
         <p:spPr>
           <a:xfrm>
-            <a:off x="457200" y="1783080"/>
-            <a:ext cx="5532120" cy="1783080"/>
+            <a:off x="457200" y="1444752"/>
+            <a:ext cx="5532120" cy="1371600"/>
           </a:xfrm>
           <a:prstGeom prst="roundRect">
             <a:avLst/>
@@ -24966,8 +24966,8 @@
         </p:nvSpPr>
         <p:spPr>
           <a:xfrm>
-            <a:off x="457200" y="1783080"/>
-            <a:ext cx="128016" cy="1783080"/>
+            <a:off x="457200" y="1444752"/>
+            <a:ext cx="128016" cy="1371600"/>
           </a:xfrm>
           <a:prstGeom prst="rect">
             <a:avLst/>
@@ -25010,8 +25010,8 @@
         </p:nvSpPr>
         <p:spPr>
           <a:xfrm>
-            <a:off x="731520" y="1892808"/>
-            <a:ext cx="5120640" cy="457200"/>
+            <a:off x="731520" y="1517904"/>
+            <a:ext cx="5120640" cy="384048"/>
           </a:xfrm>
           <a:prstGeom prst="rect">
             <a:avLst/>
@@ -25050,8 +25050,8 @@
         </p:nvSpPr>
         <p:spPr>
           <a:xfrm>
-            <a:off x="731520" y="2350008"/>
-            <a:ext cx="5120640" cy="1143000"/>
+            <a:off x="731520" y="1901952"/>
+            <a:ext cx="5120640" cy="868680"/>
           </a:xfrm>
           <a:prstGeom prst="rect">
             <a:avLst/>
@@ -25070,7 +25070,7 @@
               </a:spcAft>
             </a:pPr>
             <a:r>
-              <a:rPr sz="1150" b="0">
+              <a:rPr sz="1050" b="0">
                 <a:solidFill>
                   <a:srgbClr val="475467"/>
                 </a:solidFill>
@@ -25090,8 +25090,8 @@
         </p:nvSpPr>
         <p:spPr>
           <a:xfrm>
-            <a:off x="6217920" y="1783080"/>
-            <a:ext cx="5532120" cy="1783080"/>
+            <a:off x="6217920" y="1444752"/>
+            <a:ext cx="5532120" cy="1371600"/>
           </a:xfrm>
           <a:prstGeom prst="roundRect">
             <a:avLst/>
@@ -25136,8 +25136,8 @@
         </p:nvSpPr>
         <p:spPr>
           <a:xfrm>
-            <a:off x="6217920" y="1783080"/>
-            <a:ext cx="128016" cy="1783080"/>
+            <a:off x="6217920" y="1444752"/>
+            <a:ext cx="128016" cy="1371600"/>
           </a:xfrm>
           <a:prstGeom prst="rect">
             <a:avLst/>
@@ -25180,8 +25180,8 @@
         </p:nvSpPr>
         <p:spPr>
           <a:xfrm>
-            <a:off x="6492240" y="1892808"/>
-            <a:ext cx="5120640" cy="457200"/>
+            <a:off x="6492240" y="1517904"/>
+            <a:ext cx="5120640" cy="384048"/>
           </a:xfrm>
           <a:prstGeom prst="rect">
             <a:avLst/>
@@ -25220,8 +25220,8 @@
         </p:nvSpPr>
         <p:spPr>
           <a:xfrm>
-            <a:off x="6492240" y="2350008"/>
-            <a:ext cx="5120640" cy="1143000"/>
+            <a:off x="6492240" y="1901952"/>
+            <a:ext cx="5120640" cy="868680"/>
           </a:xfrm>
           <a:prstGeom prst="rect">
             <a:avLst/>
@@ -25240,7 +25240,7 @@
               </a:spcAft>
             </a:pPr>
             <a:r>
-              <a:rPr sz="1150" b="0">
+              <a:rPr sz="1050" b="0">
                 <a:solidFill>
                   <a:srgbClr val="475467"/>
                 </a:solidFill>
@@ -25260,8 +25260,8 @@
         </p:nvSpPr>
         <p:spPr>
           <a:xfrm>
-            <a:off x="457200" y="3749039"/>
-            <a:ext cx="5532120" cy="1783080"/>
+            <a:off x="457200" y="2907792"/>
+            <a:ext cx="5532120" cy="1371600"/>
           </a:xfrm>
           <a:prstGeom prst="roundRect">
             <a:avLst/>
@@ -25306,8 +25306,8 @@
         </p:nvSpPr>
         <p:spPr>
           <a:xfrm>
-            <a:off x="457200" y="3749039"/>
-            <a:ext cx="128016" cy="1783080"/>
+            <a:off x="457200" y="2907792"/>
+            <a:ext cx="128016" cy="1371600"/>
           </a:xfrm>
           <a:prstGeom prst="rect">
             <a:avLst/>
@@ -25350,8 +25350,8 @@
         </p:nvSpPr>
         <p:spPr>
           <a:xfrm>
-            <a:off x="731520" y="3858767"/>
-            <a:ext cx="5120640" cy="457200"/>
+            <a:off x="731520" y="2980944"/>
+            <a:ext cx="5120640" cy="384048"/>
           </a:xfrm>
           <a:prstGeom prst="rect">
             <a:avLst/>
@@ -25390,8 +25390,8 @@
         </p:nvSpPr>
         <p:spPr>
           <a:xfrm>
-            <a:off x="731520" y="4315967"/>
-            <a:ext cx="5120640" cy="1143000"/>
+            <a:off x="731520" y="3364992"/>
+            <a:ext cx="5120640" cy="868680"/>
           </a:xfrm>
           <a:prstGeom prst="rect">
             <a:avLst/>
@@ -25410,7 +25410,7 @@
               </a:spcAft>
             </a:pPr>
             <a:r>
-              <a:rPr sz="1150" b="0">
+              <a:rPr sz="1050" b="0">
                 <a:solidFill>
                   <a:srgbClr val="475467"/>
                 </a:solidFill>
@@ -25430,8 +25430,8 @@
         </p:nvSpPr>
         <p:spPr>
           <a:xfrm>
-            <a:off x="6217920" y="3749039"/>
-            <a:ext cx="5532120" cy="1783080"/>
+            <a:off x="6217920" y="2907792"/>
+            <a:ext cx="5532120" cy="1371600"/>
           </a:xfrm>
           <a:prstGeom prst="roundRect">
             <a:avLst/>
@@ -25476,8 +25476,8 @@
         </p:nvSpPr>
         <p:spPr>
           <a:xfrm>
-            <a:off x="6217920" y="3749039"/>
-            <a:ext cx="128016" cy="1783080"/>
+            <a:off x="6217920" y="2907792"/>
+            <a:ext cx="128016" cy="1371600"/>
           </a:xfrm>
           <a:prstGeom prst="rect">
             <a:avLst/>
@@ -25520,8 +25520,8 @@
         </p:nvSpPr>
         <p:spPr>
           <a:xfrm>
-            <a:off x="6492240" y="3858767"/>
-            <a:ext cx="5120640" cy="457200"/>
+            <a:off x="6492240" y="2980944"/>
+            <a:ext cx="5120640" cy="384048"/>
           </a:xfrm>
           <a:prstGeom prst="rect">
             <a:avLst/>
@@ -25560,8 +25560,8 @@
         </p:nvSpPr>
         <p:spPr>
           <a:xfrm>
-            <a:off x="6492240" y="4315967"/>
-            <a:ext cx="5120640" cy="1143000"/>
+            <a:off x="6492240" y="3364992"/>
+            <a:ext cx="5120640" cy="868680"/>
           </a:xfrm>
           <a:prstGeom prst="rect">
             <a:avLst/>
@@ -25580,7 +25580,7 @@
               </a:spcAft>
             </a:pPr>
             <a:r>
-              <a:rPr sz="1150" b="0">
+              <a:rPr sz="1050" b="0">
                 <a:solidFill>
                   <a:srgbClr val="475467"/>
                 </a:solidFill>
@@ -25600,8 +25600,8 @@
         </p:nvSpPr>
         <p:spPr>
           <a:xfrm>
-            <a:off x="457200" y="5760720"/>
-            <a:ext cx="11247120" cy="685800"/>
+            <a:off x="457200" y="5925312"/>
+            <a:ext cx="11247120" cy="475488"/>
           </a:xfrm>
           <a:prstGeom prst="roundRect">
             <a:avLst/>
@@ -25646,8 +25646,8 @@
         </p:nvSpPr>
         <p:spPr>
           <a:xfrm>
-            <a:off x="685800" y="5760720"/>
-            <a:ext cx="10881360" cy="685800"/>
+            <a:off x="685800" y="5925312"/>
+            <a:ext cx="10881360" cy="475488"/>
           </a:xfrm>
           <a:prstGeom prst="rect">
             <a:avLst/>
@@ -25666,7 +25666,7 @@
               </a:spcAft>
             </a:pPr>
             <a:r>
-              <a:rPr sz="1300" b="1">
+              <a:rPr sz="1200" b="1">
                 <a:solidFill>
                   <a:srgbClr val="065F46"/>
                 </a:solidFill>
@@ -25754,6 +25754,206 @@
                 <a:ea typeface="Noto Sans CJK SC"/>
               </a:rPr>
               <a:t>VLA 大模型技术分享报告</a:t>
+            </a:r>
+          </a:p>
+        </p:txBody>
+      </p:sp>
+      <p:sp>
+        <p:nvSpPr>
+          <p:cNvPr id="26" name="Rounded Rectangle 25"/>
+          <p:cNvSpPr/>
+          <p:nvPr/>
+        </p:nvSpPr>
+        <p:spPr>
+          <a:xfrm>
+            <a:off x="457200" y="4416552"/>
+            <a:ext cx="11292840" cy="1389888"/>
+          </a:xfrm>
+          <a:prstGeom prst="roundRect">
+            <a:avLst/>
+          </a:prstGeom>
+          <a:solidFill>
+            <a:srgbClr val="FFFBEB"/>
+          </a:solidFill>
+          <a:ln w="12700">
+            <a:solidFill>
+              <a:srgbClr val="D97706"/>
+            </a:solidFill>
+          </a:ln>
+          <a:effectLst/>
+        </p:spPr>
+        <p:style>
+          <a:lnRef idx="1">
+            <a:schemeClr val="accent1"/>
+          </a:lnRef>
+          <a:fillRef idx="3">
+            <a:schemeClr val="accent1"/>
+          </a:fillRef>
+          <a:effectRef idx="2">
+            <a:schemeClr val="accent1"/>
+          </a:effectRef>
+          <a:fontRef idx="minor">
+            <a:schemeClr val="lt1"/>
+          </a:fontRef>
+        </p:style>
+        <p:txBody>
+          <a:bodyPr rtlCol="0" anchor="ctr"/>
+          <a:lstStyle/>
+          <a:p/>
+        </p:txBody>
+      </p:sp>
+      <p:sp>
+        <p:nvSpPr>
+          <p:cNvPr id="27" name="Rectangle 26"/>
+          <p:cNvSpPr/>
+          <p:nvPr/>
+        </p:nvSpPr>
+        <p:spPr>
+          <a:xfrm>
+            <a:off x="457200" y="4416552"/>
+            <a:ext cx="128016" cy="1389888"/>
+          </a:xfrm>
+          <a:prstGeom prst="rect">
+            <a:avLst/>
+          </a:prstGeom>
+          <a:solidFill>
+            <a:srgbClr val="D97706"/>
+          </a:solidFill>
+          <a:ln>
+            <a:noFill/>
+          </a:ln>
+          <a:effectLst/>
+        </p:spPr>
+        <p:style>
+          <a:lnRef idx="1">
+            <a:schemeClr val="accent1"/>
+          </a:lnRef>
+          <a:fillRef idx="3">
+            <a:schemeClr val="accent1"/>
+          </a:fillRef>
+          <a:effectRef idx="2">
+            <a:schemeClr val="accent1"/>
+          </a:effectRef>
+          <a:fontRef idx="minor">
+            <a:schemeClr val="lt1"/>
+          </a:fontRef>
+        </p:style>
+        <p:txBody>
+          <a:bodyPr rtlCol="0" anchor="ctr"/>
+          <a:lstStyle/>
+          <a:p>
+            <a:pPr algn="ctr"/>
+          </a:p>
+        </p:txBody>
+      </p:sp>
+      <p:sp>
+        <p:nvSpPr>
+          <p:cNvPr id="28" name="TextBox 27"/>
+          <p:cNvSpPr txBox="1"/>
+          <p:nvPr/>
+        </p:nvSpPr>
+        <p:spPr>
+          <a:xfrm>
+            <a:off x="731520" y="4462272"/>
+            <a:ext cx="10789920" cy="320040"/>
+          </a:xfrm>
+          <a:prstGeom prst="rect">
+            <a:avLst/>
+          </a:prstGeom>
+          <a:noFill/>
+        </p:spPr>
+        <p:txBody>
+          <a:bodyPr wrap="square">
+            <a:spAutoFit/>
+          </a:bodyPr>
+          <a:lstStyle/>
+          <a:p>
+            <a:r>
+              <a:rPr sz="1300" b="1">
+                <a:solidFill>
+                  <a:srgbClr val="B45309"/>
+                </a:solidFill>
+                <a:latin typeface="Noto Sans CJK SC"/>
+              </a:rPr>
+              <a:t>当前阶段的主要不足（与四大优势相对照）</a:t>
+            </a:r>
+          </a:p>
+        </p:txBody>
+      </p:sp>
+      <p:sp>
+        <p:nvSpPr>
+          <p:cNvPr id="29" name="TextBox 28"/>
+          <p:cNvSpPr txBox="1"/>
+          <p:nvPr/>
+        </p:nvSpPr>
+        <p:spPr>
+          <a:xfrm>
+            <a:off x="731520" y="4773168"/>
+            <a:ext cx="10835640" cy="1005840"/>
+          </a:xfrm>
+          <a:prstGeom prst="rect">
+            <a:avLst/>
+          </a:prstGeom>
+          <a:noFill/>
+        </p:spPr>
+        <p:txBody>
+          <a:bodyPr wrap="square">
+            <a:spAutoFit/>
+          </a:bodyPr>
+          <a:lstStyle/>
+          <a:p>
+            <a:r>
+              <a:rPr sz="950" b="0">
+                <a:solidFill>
+                  <a:srgbClr val="475467"/>
+                </a:solidFill>
+                <a:latin typeface="Noto Sans CJK SC"/>
+              </a:rPr>
+              <a:t>• 数据仍稀缺昂贵：OXE 百万级轨迹 vs LLM 万亿级 token，相差 5–6 个数量级；遥操作采集人力密集，仿真存在 sim-to-real gap</a:t>
+            </a:r>
+          </a:p>
+          <a:p>
+            <a:r>
+              <a:rPr sz="950" b="0">
+                <a:solidFill>
+                  <a:srgbClr val="475467"/>
+                </a:solidFill>
+                <a:latin typeface="Noto Sans CJK SC"/>
+              </a:rPr>
+              <a:t>• 物理泛化脆弱：换光照/视角/物体位置易失败，真实成功率约 50%–90%，距工业级 99.9%+ 仍有巨大差距；长时序任务成功率随步骤衰减</a:t>
+            </a:r>
+          </a:p>
+          <a:p>
+            <a:r>
+              <a:rPr sz="950" b="0">
+                <a:solidFill>
+                  <a:srgbClr val="475467"/>
+                </a:solidFill>
+                <a:latin typeface="Noto Sans CJK SC"/>
+              </a:rPr>
+              <a:t>• 端到端黑箱：失败难定位（感知/理解/控制），缺乏形式化安全保证，幻觉问题从 LLM 继承，人机共处场景是硬伤</a:t>
+            </a:r>
+          </a:p>
+          <a:p>
+            <a:r>
+              <a:rPr sz="950" b="0">
+                <a:solidFill>
+                  <a:srgbClr val="475467"/>
+                </a:solidFill>
+                <a:latin typeface="Noto Sans CJK SC"/>
+              </a:rPr>
+              <a:t>• 推理延迟与模态缺失：十亿级参数推理频率 vs 高频控制需求矛盾（π0 50Hz、GR00T 双系统均为折中）；触觉/力觉缺失，接触密集任务能力有限</a:t>
+            </a:r>
+          </a:p>
+          <a:p>
+            <a:r>
+              <a:rPr sz="950" b="0">
+                <a:solidFill>
+                  <a:srgbClr val="475467"/>
+                </a:solidFill>
+                <a:latin typeface="Noto Sans CJK SC"/>
+              </a:rPr>
+              <a:t>• 工程化不成熟：评测基准不统一、结果不可横向比较；失败恢复与持续学习尚在早期（π*0.6 RECAP 正在探索）</a:t>
             </a:r>
           </a:p>
         </p:txBody>

</xml_diff>

<commit_message>
Redraw VLA architecture diagram in 合并图.jpg graphic style and update PPT
</commit_message>
<xml_diff>
--- a/reports/VLA大模型技术分享报告.pptx
+++ b/reports/VLA大模型技术分享报告.pptx
@@ -5146,8 +5146,8 @@
         </p:nvSpPr>
         <p:spPr>
           <a:xfrm>
-            <a:off x="1650239" y="987552"/>
-            <a:ext cx="8891217" cy="5111496"/>
+            <a:off x="1637640" y="987552"/>
+            <a:ext cx="8916416" cy="5111496"/>
           </a:xfrm>
           <a:prstGeom prst="roundRect">
             <a:avLst/>
@@ -5366,8 +5366,8 @@
         </p:blipFill>
         <p:spPr>
           <a:xfrm>
-            <a:off x="1759967" y="1097280"/>
-            <a:ext cx="8671761" cy="4892040"/>
+            <a:off x="1747368" y="1097280"/>
+            <a:ext cx="8696960" cy="4892040"/>
           </a:xfrm>
           <a:prstGeom prst="rect">
             <a:avLst/>

</xml_diff>

<commit_message>
Add speaker notes to 8 slides based on Q&A deep-dive explanations
Co-authored-by: liumouyun0413 <275648616+liumouyun0413@users.noreply.github.com>
</commit_message>
<xml_diff>
--- a/reports/VLA大模型技术分享报告.pptx
+++ b/reports/VLA大模型技术分享报告.pptx
@@ -134,6 +134,1087 @@
     </a:lvl9pPr>
   </p:defaultTextStyle>
 </p:presentation>
+</file>
+
+<file path=ppt/notesMasters/notesMaster1.xml><?xml version="1.0" encoding="utf-8"?>
+<p:notesMaster xmlns:a="http://schemas.openxmlformats.org/drawingml/2006/main" xmlns:p="http://schemas.openxmlformats.org/presentationml/2006/main" xmlns:r="http://schemas.openxmlformats.org/officeDocument/2006/relationships">
+  <p:cSld>
+    <p:bg>
+      <p:bgRef idx="1001">
+        <a:schemeClr val="bg1"/>
+      </p:bgRef>
+    </p:bg>
+    <p:spTree>
+      <p:nvGrpSpPr>
+        <p:cNvPr id="1" name=""/>
+        <p:cNvGrpSpPr/>
+        <p:nvPr/>
+      </p:nvGrpSpPr>
+      <p:grpSpPr>
+        <a:xfrm>
+          <a:off x="0" y="0"/>
+          <a:ext cx="0" cy="0"/>
+          <a:chOff x="0" y="0"/>
+          <a:chExt cx="0" cy="0"/>
+        </a:xfrm>
+      </p:grpSpPr>
+      <p:sp>
+        <p:nvSpPr>
+          <p:cNvPr id="2" name="Header Placeholder 1"/>
+          <p:cNvSpPr>
+            <a:spLocks noGrp="1"/>
+          </p:cNvSpPr>
+          <p:nvPr>
+            <p:ph type="hdr" sz="quarter"/>
+          </p:nvPr>
+        </p:nvSpPr>
+        <p:spPr>
+          <a:xfrm>
+            <a:off x="0" y="0"/>
+            <a:ext cx="2971800" cy="457200"/>
+          </a:xfrm>
+          <a:prstGeom prst="rect">
+            <a:avLst/>
+          </a:prstGeom>
+        </p:spPr>
+        <p:txBody>
+          <a:bodyPr vert="horz" lIns="91440" tIns="45720" rIns="91440" bIns="45720" rtlCol="0"/>
+          <a:lstStyle>
+            <a:lvl1pPr algn="l">
+              <a:defRPr sz="1200"/>
+            </a:lvl1pPr>
+          </a:lstStyle>
+          <a:p>
+            <a:endParaRPr lang="en-US"/>
+          </a:p>
+        </p:txBody>
+      </p:sp>
+      <p:sp>
+        <p:nvSpPr>
+          <p:cNvPr id="3" name="Date Placeholder 2"/>
+          <p:cNvSpPr>
+            <a:spLocks noGrp="1"/>
+          </p:cNvSpPr>
+          <p:nvPr>
+            <p:ph type="dt" idx="1"/>
+          </p:nvPr>
+        </p:nvSpPr>
+        <p:spPr>
+          <a:xfrm>
+            <a:off x="3884613" y="0"/>
+            <a:ext cx="2971800" cy="457200"/>
+          </a:xfrm>
+          <a:prstGeom prst="rect">
+            <a:avLst/>
+          </a:prstGeom>
+        </p:spPr>
+        <p:txBody>
+          <a:bodyPr vert="horz" lIns="91440" tIns="45720" rIns="91440" bIns="45720" rtlCol="0"/>
+          <a:lstStyle>
+            <a:lvl1pPr algn="r">
+              <a:defRPr sz="1200"/>
+            </a:lvl1pPr>
+          </a:lstStyle>
+          <a:p>
+            <a:fld id="{0F89C1C7-3DCD-1040-A9CF-14679D8B5DDD}" type="datetimeFigureOut">
+              <a:rPr lang="en-US" smtClean="0"/>
+              <a:t>10/17/16</a:t>
+            </a:fld>
+            <a:endParaRPr lang="en-US"/>
+          </a:p>
+        </p:txBody>
+      </p:sp>
+      <p:sp>
+        <p:nvSpPr>
+          <p:cNvPr id="4" name="Slide Image Placeholder 3"/>
+          <p:cNvSpPr>
+            <a:spLocks noGrp="1" noRot="1" noChangeAspect="1"/>
+          </p:cNvSpPr>
+          <p:nvPr>
+            <p:ph type="sldImg" idx="2"/>
+          </p:nvPr>
+        </p:nvSpPr>
+        <p:spPr>
+          <a:xfrm>
+            <a:off x="1143000" y="685800"/>
+            <a:ext cx="4572000" cy="3429000"/>
+          </a:xfrm>
+          <a:prstGeom prst="rect">
+            <a:avLst/>
+          </a:prstGeom>
+          <a:noFill/>
+          <a:ln w="12700">
+            <a:solidFill>
+              <a:prstClr val="black"/>
+            </a:solidFill>
+          </a:ln>
+        </p:spPr>
+        <p:txBody>
+          <a:bodyPr vert="horz" lIns="91440" tIns="45720" rIns="91440" bIns="45720" rtlCol="0" anchor="ctr"/>
+          <a:lstStyle/>
+          <a:p>
+            <a:endParaRPr lang="en-US"/>
+          </a:p>
+        </p:txBody>
+      </p:sp>
+      <p:sp>
+        <p:nvSpPr>
+          <p:cNvPr id="5" name="Notes Placeholder 4"/>
+          <p:cNvSpPr>
+            <a:spLocks noGrp="1"/>
+          </p:cNvSpPr>
+          <p:nvPr>
+            <p:ph type="body" sz="quarter" idx="3"/>
+          </p:nvPr>
+        </p:nvSpPr>
+        <p:spPr>
+          <a:xfrm>
+            <a:off x="685800" y="4343400"/>
+            <a:ext cx="5486400" cy="4114800"/>
+          </a:xfrm>
+          <a:prstGeom prst="rect">
+            <a:avLst/>
+          </a:prstGeom>
+        </p:spPr>
+        <p:txBody>
+          <a:bodyPr vert="horz" lIns="91440" tIns="45720" rIns="91440" bIns="45720" rtlCol="0"/>
+          <a:lstStyle/>
+          <a:p>
+            <a:pPr lvl="0"/>
+            <a:r>
+              <a:rPr lang="en-US" smtClean="0"/>
+              <a:t>Click to edit Master text styles</a:t>
+            </a:r>
+          </a:p>
+          <a:p>
+            <a:pPr lvl="1"/>
+            <a:r>
+              <a:rPr lang="en-US" smtClean="0"/>
+              <a:t>Second level</a:t>
+            </a:r>
+          </a:p>
+          <a:p>
+            <a:pPr lvl="2"/>
+            <a:r>
+              <a:rPr lang="en-US" smtClean="0"/>
+              <a:t>Third level</a:t>
+            </a:r>
+          </a:p>
+          <a:p>
+            <a:pPr lvl="3"/>
+            <a:r>
+              <a:rPr lang="en-US" smtClean="0"/>
+              <a:t>Fourth level</a:t>
+            </a:r>
+          </a:p>
+          <a:p>
+            <a:pPr lvl="4"/>
+            <a:r>
+              <a:rPr lang="en-US" smtClean="0"/>
+              <a:t>Fifth level</a:t>
+            </a:r>
+            <a:endParaRPr lang="en-US"/>
+          </a:p>
+        </p:txBody>
+      </p:sp>
+      <p:sp>
+        <p:nvSpPr>
+          <p:cNvPr id="6" name="Footer Placeholder 5"/>
+          <p:cNvSpPr>
+            <a:spLocks noGrp="1"/>
+          </p:cNvSpPr>
+          <p:nvPr>
+            <p:ph type="ftr" sz="quarter" idx="4"/>
+          </p:nvPr>
+        </p:nvSpPr>
+        <p:spPr>
+          <a:xfrm>
+            <a:off x="0" y="8685213"/>
+            <a:ext cx="2971800" cy="457200"/>
+          </a:xfrm>
+          <a:prstGeom prst="rect">
+            <a:avLst/>
+          </a:prstGeom>
+        </p:spPr>
+        <p:txBody>
+          <a:bodyPr vert="horz" lIns="91440" tIns="45720" rIns="91440" bIns="45720" rtlCol="0" anchor="b"/>
+          <a:lstStyle>
+            <a:lvl1pPr algn="l">
+              <a:defRPr sz="1200"/>
+            </a:lvl1pPr>
+          </a:lstStyle>
+          <a:p>
+            <a:endParaRPr lang="en-US"/>
+          </a:p>
+        </p:txBody>
+      </p:sp>
+      <p:sp>
+        <p:nvSpPr>
+          <p:cNvPr id="7" name="Slide Number Placeholder 6"/>
+          <p:cNvSpPr>
+            <a:spLocks noGrp="1"/>
+          </p:cNvSpPr>
+          <p:nvPr>
+            <p:ph type="sldNum" sz="quarter" idx="5"/>
+          </p:nvPr>
+        </p:nvSpPr>
+        <p:spPr>
+          <a:xfrm>
+            <a:off x="3884613" y="8685213"/>
+            <a:ext cx="2971800" cy="457200"/>
+          </a:xfrm>
+          <a:prstGeom prst="rect">
+            <a:avLst/>
+          </a:prstGeom>
+        </p:spPr>
+        <p:txBody>
+          <a:bodyPr vert="horz" lIns="91440" tIns="45720" rIns="91440" bIns="45720" rtlCol="0" anchor="b"/>
+          <a:lstStyle>
+            <a:lvl1pPr algn="r">
+              <a:defRPr sz="1200"/>
+            </a:lvl1pPr>
+          </a:lstStyle>
+          <a:p>
+            <a:fld id="{BB5E49A5-4136-284D-997B-48E1D791AD67}" type="slidenum">
+              <a:rPr lang="en-US" smtClean="0"/>
+              <a:t>‹#›</a:t>
+            </a:fld>
+            <a:endParaRPr lang="en-US"/>
+          </a:p>
+        </p:txBody>
+      </p:sp>
+    </p:spTree>
+    <p:extLst>
+      <p:ext uri="{BB962C8B-B14F-4D97-AF65-F5344CB8AC3E}">
+        <p14:creationId xmlns:p14="http://schemas.microsoft.com/office/powerpoint/2010/main" val="2623252185"/>
+      </p:ext>
+    </p:extLst>
+  </p:cSld>
+  <p:clrMap bg1="lt1" tx1="dk1" bg2="lt2" tx2="dk2" accent1="accent1" accent2="accent2" accent3="accent3" accent4="accent4" accent5="accent5" accent6="accent6" hlink="hlink" folHlink="folHlink"/>
+  <p:notesStyle>
+    <a:lvl1pPr marL="0" algn="l" defTabSz="457200" rtl="0" eaLnBrk="1" latinLnBrk="0" hangingPunct="1">
+      <a:defRPr sz="1200" kern="1200">
+        <a:solidFill>
+          <a:schemeClr val="tx1"/>
+        </a:solidFill>
+        <a:latin typeface="+mn-lt"/>
+        <a:ea typeface="+mn-ea"/>
+        <a:cs typeface="+mn-cs"/>
+      </a:defRPr>
+    </a:lvl1pPr>
+    <a:lvl2pPr marL="457200" algn="l" defTabSz="457200" rtl="0" eaLnBrk="1" latinLnBrk="0" hangingPunct="1">
+      <a:defRPr sz="1200" kern="1200">
+        <a:solidFill>
+          <a:schemeClr val="tx1"/>
+        </a:solidFill>
+        <a:latin typeface="+mn-lt"/>
+        <a:ea typeface="+mn-ea"/>
+        <a:cs typeface="+mn-cs"/>
+      </a:defRPr>
+    </a:lvl2pPr>
+    <a:lvl3pPr marL="914400" algn="l" defTabSz="457200" rtl="0" eaLnBrk="1" latinLnBrk="0" hangingPunct="1">
+      <a:defRPr sz="1200" kern="1200">
+        <a:solidFill>
+          <a:schemeClr val="tx1"/>
+        </a:solidFill>
+        <a:latin typeface="+mn-lt"/>
+        <a:ea typeface="+mn-ea"/>
+        <a:cs typeface="+mn-cs"/>
+      </a:defRPr>
+    </a:lvl3pPr>
+    <a:lvl4pPr marL="1371600" algn="l" defTabSz="457200" rtl="0" eaLnBrk="1" latinLnBrk="0" hangingPunct="1">
+      <a:defRPr sz="1200" kern="1200">
+        <a:solidFill>
+          <a:schemeClr val="tx1"/>
+        </a:solidFill>
+        <a:latin typeface="+mn-lt"/>
+        <a:ea typeface="+mn-ea"/>
+        <a:cs typeface="+mn-cs"/>
+      </a:defRPr>
+    </a:lvl4pPr>
+    <a:lvl5pPr marL="1828800" algn="l" defTabSz="457200" rtl="0" eaLnBrk="1" latinLnBrk="0" hangingPunct="1">
+      <a:defRPr sz="1200" kern="1200">
+        <a:solidFill>
+          <a:schemeClr val="tx1"/>
+        </a:solidFill>
+        <a:latin typeface="+mn-lt"/>
+        <a:ea typeface="+mn-ea"/>
+        <a:cs typeface="+mn-cs"/>
+      </a:defRPr>
+    </a:lvl5pPr>
+    <a:lvl6pPr marL="2286000" algn="l" defTabSz="457200" rtl="0" eaLnBrk="1" latinLnBrk="0" hangingPunct="1">
+      <a:defRPr sz="1200" kern="1200">
+        <a:solidFill>
+          <a:schemeClr val="tx1"/>
+        </a:solidFill>
+        <a:latin typeface="+mn-lt"/>
+        <a:ea typeface="+mn-ea"/>
+        <a:cs typeface="+mn-cs"/>
+      </a:defRPr>
+    </a:lvl6pPr>
+    <a:lvl7pPr marL="2743200" algn="l" defTabSz="457200" rtl="0" eaLnBrk="1" latinLnBrk="0" hangingPunct="1">
+      <a:defRPr sz="1200" kern="1200">
+        <a:solidFill>
+          <a:schemeClr val="tx1"/>
+        </a:solidFill>
+        <a:latin typeface="+mn-lt"/>
+        <a:ea typeface="+mn-ea"/>
+        <a:cs typeface="+mn-cs"/>
+      </a:defRPr>
+    </a:lvl7pPr>
+    <a:lvl8pPr marL="3200400" algn="l" defTabSz="457200" rtl="0" eaLnBrk="1" latinLnBrk="0" hangingPunct="1">
+      <a:defRPr sz="1200" kern="1200">
+        <a:solidFill>
+          <a:schemeClr val="tx1"/>
+        </a:solidFill>
+        <a:latin typeface="+mn-lt"/>
+        <a:ea typeface="+mn-ea"/>
+        <a:cs typeface="+mn-cs"/>
+      </a:defRPr>
+    </a:lvl8pPr>
+    <a:lvl9pPr marL="3657600" algn="l" defTabSz="457200" rtl="0" eaLnBrk="1" latinLnBrk="0" hangingPunct="1">
+      <a:defRPr sz="1200" kern="1200">
+        <a:solidFill>
+          <a:schemeClr val="tx1"/>
+        </a:solidFill>
+        <a:latin typeface="+mn-lt"/>
+        <a:ea typeface="+mn-ea"/>
+        <a:cs typeface="+mn-cs"/>
+      </a:defRPr>
+    </a:lvl9pPr>
+  </p:notesStyle>
+</p:notesMaster>
+</file>
+
+<file path=ppt/notesSlides/notesSlide1.xml><?xml version="1.0" encoding="utf-8"?>
+<p:notes xmlns:a="http://schemas.openxmlformats.org/drawingml/2006/main" xmlns:p="http://schemas.openxmlformats.org/presentationml/2006/main" xmlns:r="http://schemas.openxmlformats.org/officeDocument/2006/relationships">
+  <p:cSld>
+    <p:spTree>
+      <p:nvGrpSpPr>
+        <p:cNvPr id="1" name=""/>
+        <p:cNvGrpSpPr/>
+        <p:nvPr/>
+      </p:nvGrpSpPr>
+      <p:grpSpPr>
+        <a:xfrm>
+          <a:off x="0" y="0"/>
+          <a:ext cx="0" cy="0"/>
+          <a:chOff x="0" y="0"/>
+          <a:chExt cx="0" cy="0"/>
+        </a:xfrm>
+      </p:grpSpPr>
+      <p:sp>
+        <p:nvSpPr>
+          <p:cNvPr id="2" name="Slide Image Placeholder 1"/>
+          <p:cNvSpPr>
+            <a:spLocks noGrp="1"/>
+          </p:cNvSpPr>
+          <p:nvPr>
+            <p:ph type="sldImg" idx="2"/>
+          </p:nvPr>
+        </p:nvSpPr>
+        <p:spPr/>
+      </p:sp>
+      <p:sp>
+        <p:nvSpPr>
+          <p:cNvPr id="3" name="Notes Placeholder 2"/>
+          <p:cNvSpPr>
+            <a:spLocks noGrp="1"/>
+          </p:cNvSpPr>
+          <p:nvPr>
+            <p:ph type="body" idx="3" sz="quarter"/>
+          </p:nvPr>
+        </p:nvSpPr>
+        <p:spPr/>
+        <p:txBody>
+          <a:bodyPr/>
+          <a:lstStyle/>
+          <a:p>
+            <a:r>
+              <a:t>【公式解读】π_θ(a_{t:t+H} | o_t, ℓ) 读作：在给定当前观测 o_t 和语言指令 ℓ 的条件下，策略 π（参数为 θ）输出未来 H 步动作块的条件概率分布。</a:t>
+            </a:r>
+          </a:p>
+          <a:p/>
+          <a:p>
+            <a:r>
+              <a:t>【π_θ 是什么】π 是强化学习/机器人学中"策略"（policy）的标准记号，在 VLA 场景下就是整个 VLA 大模型本身（RT-2、π0、GR00T 等）；下标 θ 表示模型全部可学习参数。"学习策略"= 通过模仿学习（行为克隆）调整 θ，使模型输出的动作分布逼近人类演示分布。</a:t>
+            </a:r>
+          </a:p>
+          <a:p/>
+          <a:p>
+            <a:r>
+              <a:t>【关键点：分布而非函数】同一任务往往有多种合理做法（从左绕/从右绕抓杯子都行），演示数据天然是多模态分布，所以模型学的是 P(动作|观测,指令) 这个分布，执行时从中采样。三大流派只是用不同方式表示和采样这同一个分布：流派一（RT）自回归逐 token；流派二（ACT）CVAE 隐变量 z；流派三（π0/GR00T）扩散/流匹配去噪。</a:t>
+            </a:r>
+          </a:p>
+          <a:p/>
+          <a:p>
+            <a:r>
+              <a:t>【为什么输出动作块而非单步】1) 大模型推理慢，一次预测 H 步降低决策频率，支撑高频控制；2) 动作更连贯，避免逐步预测的抖动与复合误差；3) 对演示数据的非马尔可夫性（如停顿）更鲁棒。</a:t>
+            </a:r>
+          </a:p>
+          <a:p/>
+          <a:p>
+            <a:r>
+              <a:t>【一句话总结】π_θ 就是 VLA 模型本身——把"图像+身体状态+语言指令"映射为"未来一小段动作序列概率分布"的大型神经网络。</a:t>
+            </a:r>
+          </a:p>
+        </p:txBody>
+      </p:sp>
+      <p:sp>
+        <p:nvSpPr>
+          <p:cNvPr id="4" name="Slide Number Placeholder 3"/>
+          <p:cNvSpPr>
+            <a:spLocks noGrp="1"/>
+          </p:cNvSpPr>
+          <p:nvPr>
+            <p:ph type="sldNum" idx="5" sz="quarter"/>
+          </p:nvPr>
+        </p:nvSpPr>
+        <p:spPr/>
+      </p:sp>
+    </p:spTree>
+  </p:cSld>
+  <p:clrMapOvr>
+    <a:masterClrMapping/>
+  </p:clrMapOvr>
+</p:notes>
+</file>
+
+<file path=ppt/notesSlides/notesSlide2.xml><?xml version="1.0" encoding="utf-8"?>
+<p:notes xmlns:a="http://schemas.openxmlformats.org/drawingml/2006/main" xmlns:p="http://schemas.openxmlformats.org/presentationml/2006/main" xmlns:r="http://schemas.openxmlformats.org/officeDocument/2006/relationships">
+  <p:cSld>
+    <p:spTree>
+      <p:nvGrpSpPr>
+        <p:cNvPr id="1" name=""/>
+        <p:cNvGrpSpPr/>
+        <p:nvPr/>
+      </p:nvGrpSpPr>
+      <p:grpSpPr>
+        <a:xfrm>
+          <a:off x="0" y="0"/>
+          <a:ext cx="0" cy="0"/>
+          <a:chOff x="0" y="0"/>
+          <a:chExt cx="0" cy="0"/>
+        </a:xfrm>
+      </p:grpSpPr>
+      <p:sp>
+        <p:nvSpPr>
+          <p:cNvPr id="2" name="Slide Image Placeholder 1"/>
+          <p:cNvSpPr>
+            <a:spLocks noGrp="1"/>
+          </p:cNvSpPr>
+          <p:nvPr>
+            <p:ph type="sldImg" idx="2"/>
+          </p:nvPr>
+        </p:nvSpPr>
+        <p:spPr/>
+      </p:sp>
+      <p:sp>
+        <p:nvSpPr>
+          <p:cNvPr id="3" name="Notes Placeholder 2"/>
+          <p:cNvSpPr>
+            <a:spLocks noGrp="1"/>
+          </p:cNvSpPr>
+          <p:nvPr>
+            <p:ph type="body" idx="3" sz="quarter"/>
+          </p:nvPr>
+        </p:nvSpPr>
+        <p:spPr/>
+        <p:txBody>
+          <a:bodyPr/>
+          <a:lstStyle/>
+          <a:p>
+            <a:r>
+              <a:t>【完整公式】P(a|o,ℓ) = ∏_{i=1}^{N} P(token_i | token_&lt;i, o, ℓ)——把"整个动作的条件概率"用概率链式法则精确拆解为"逐个动作 token 条件概率的连乘"（是精确分解，不是近似）。</a:t>
+            </a:r>
+          </a:p>
+          <a:p/>
+          <a:p>
+            <a:r>
+              <a:t>【三步理解】1) 动作先离散化：11 维动作每维按范围分 256 个 bin，一个动作变成一串 token；2) 链式法则分解：每一项含义是"看到图像 o、指令 ℓ 和已生成的前几个 token 后，下一个 token 的概率"，token_&lt;i 表示第 i 个之前的所有 token；3) 这与 GPT 的 P(句子)=∏P(词_i|前面的词) 形式完全相同——所以"机器人控制 = 条件语言建模"。</a:t>
+            </a:r>
+          </a:p>
+          <a:p/>
+          <a:p>
+            <a:r>
+              <a:t>【为什么重要】1) 完全复用 LLM 技术栈：同样的交叉熵损失（下一 token 预测）、同样的自回归采样；2) RT-2 把动作 token 直接塞进文本词表（覆盖低频 token），机器人数据与互联网 VQA 数据共同微调，VLM 预训练的语义知识"涌现"式迁移到操作；3) 建模了动作维度间的相关性（token_i 以 token_&lt;i 为条件）。</a:t>
+            </a:r>
+          </a:p>
+          <a:p/>
+          <a:p>
+            <a:r>
+              <a:t>【代价/局限】256 bin 有损量化精度受限；逐 token 串行生成推理慢（RT-1 仅 3Hz）——这正是流派三改用连续动作一次生成整块的动机。</a:t>
+            </a:r>
+          </a:p>
+        </p:txBody>
+      </p:sp>
+      <p:sp>
+        <p:nvSpPr>
+          <p:cNvPr id="4" name="Slide Number Placeholder 3"/>
+          <p:cNvSpPr>
+            <a:spLocks noGrp="1"/>
+          </p:cNvSpPr>
+          <p:nvPr>
+            <p:ph type="sldNum" idx="5" sz="quarter"/>
+          </p:nvPr>
+        </p:nvSpPr>
+        <p:spPr/>
+      </p:sp>
+    </p:spTree>
+  </p:cSld>
+  <p:clrMapOvr>
+    <a:masterClrMapping/>
+  </p:clrMapOvr>
+</p:notes>
+</file>
+
+<file path=ppt/notesSlides/notesSlide3.xml><?xml version="1.0" encoding="utf-8"?>
+<p:notes xmlns:a="http://schemas.openxmlformats.org/drawingml/2006/main" xmlns:p="http://schemas.openxmlformats.org/presentationml/2006/main" xmlns:r="http://schemas.openxmlformats.org/officeDocument/2006/relationships">
+  <p:cSld>
+    <p:spTree>
+      <p:nvGrpSpPr>
+        <p:cNvPr id="1" name=""/>
+        <p:cNvGrpSpPr/>
+        <p:nvPr/>
+      </p:nvGrpSpPr>
+      <p:grpSpPr>
+        <a:xfrm>
+          <a:off x="0" y="0"/>
+          <a:ext cx="0" cy="0"/>
+          <a:chOff x="0" y="0"/>
+          <a:chExt cx="0" cy="0"/>
+        </a:xfrm>
+      </p:grpSpPr>
+      <p:sp>
+        <p:nvSpPr>
+          <p:cNvPr id="2" name="Slide Image Placeholder 1"/>
+          <p:cNvSpPr>
+            <a:spLocks noGrp="1"/>
+          </p:cNvSpPr>
+          <p:nvPr>
+            <p:ph type="sldImg" idx="2"/>
+          </p:nvPr>
+        </p:nvSpPr>
+        <p:spPr/>
+      </p:sp>
+      <p:sp>
+        <p:nvSpPr>
+          <p:cNvPr id="3" name="Notes Placeholder 2"/>
+          <p:cNvSpPr>
+            <a:spLocks noGrp="1"/>
+          </p:cNvSpPr>
+          <p:nvPr>
+            <p:ph type="body" idx="3" sz="quarter"/>
+          </p:nvPr>
+        </p:nvSpPr>
+        <p:spPr/>
+        <p:txBody>
+          <a:bodyPr/>
+          <a:lstStyle/>
+          <a:p>
+            <a:r>
+              <a:t>【讲稿要点】ACT 解决模仿学习两大痛点：复合误差（每步小误差滚雪球）→ 用动作分块；演示多模态性（左绕/右绕都对，直接回归会平均成"撞中间"）→ 用 CVAE。</a:t>
+            </a:r>
+          </a:p>
+          <a:p/>
+          <a:p>
+            <a:r>
+              <a:t>【CVAE 直觉】编码器 q(z|a,o)（仅训练时）把每条演示的"风格"（左绕还是右绕、快还是慢）压缩成隐变量 z（一张"风格便签"）；解码器拿观测+便签重建动作。做法差异被分流进 z，网络不再平均多种做法。推理时扔掉编码器、取 z=0（最典型风格），一次前向即可。注意：z=0 是"风格空间的均值"而非"动作空间的平均"，所以不会撞中间。</a:t>
+            </a:r>
+          </a:p>
+          <a:p/>
+          <a:p>
+            <a:r>
+              <a:t>【ELBO 公式解读】max_θ E[log π_θ(a_{t:t+k}|o_t,z)] − β·D_KL(q(z|a,o)‖N(0,I))。第一项重建项：解码器凭 o+z 重建 100 步演示动作（实现为 L1 损失，对演示抖动等离群值更鲁棒）；第二项 KL 正则：强迫 z 分布贴近标准高斯——信息瓶颈防止编码器把动作全塞进 z"作弊"、让 z 空间规整、保证推理时可安全取 z=0。β 权衡两项（ACT 取 β=10）：太小→解码器抄答案，太大→退化成普通回归。</a:t>
+            </a:r>
+          </a:p>
+          <a:p/>
+          <a:p>
+            <a:r>
+              <a:t>【生成机制】输出的不是 token 而是连续关节角序列！解码器用 k=100 个可学习 query 通过 cross-attention 一次前向并行输出全部 100 步（50Hz 执行 = 2 秒）。配合时间集成：每时刻重新预测新块，同一物理时刻的多个重叠预测做加权平均——滚动式闭环、动作平滑。</a:t>
+            </a:r>
+          </a:p>
+          <a:p/>
+          <a:p>
+            <a:r>
+              <a:t>【定位】仅需 50 条演示达 80–90% 成功率，但语言条件弱、任务专用；它是"小而精"的 A 侧代表，动作分块与高频控制思想被 π0/GR00T 全盘吸收。</a:t>
+            </a:r>
+          </a:p>
+        </p:txBody>
+      </p:sp>
+      <p:sp>
+        <p:nvSpPr>
+          <p:cNvPr id="4" name="Slide Number Placeholder 3"/>
+          <p:cNvSpPr>
+            <a:spLocks noGrp="1"/>
+          </p:cNvSpPr>
+          <p:nvPr>
+            <p:ph type="sldNum" idx="5" sz="quarter"/>
+          </p:nvPr>
+        </p:nvSpPr>
+        <p:spPr/>
+      </p:sp>
+    </p:spTree>
+  </p:cSld>
+  <p:clrMapOvr>
+    <a:masterClrMapping/>
+  </p:clrMapOvr>
+</p:notes>
+</file>
+
+<file path=ppt/notesSlides/notesSlide4.xml><?xml version="1.0" encoding="utf-8"?>
+<p:notes xmlns:a="http://schemas.openxmlformats.org/drawingml/2006/main" xmlns:p="http://schemas.openxmlformats.org/presentationml/2006/main" xmlns:r="http://schemas.openxmlformats.org/officeDocument/2006/relationships">
+  <p:cSld>
+    <p:spTree>
+      <p:nvGrpSpPr>
+        <p:cNvPr id="1" name=""/>
+        <p:cNvGrpSpPr/>
+        <p:nvPr/>
+      </p:nvGrpSpPr>
+      <p:grpSpPr>
+        <a:xfrm>
+          <a:off x="0" y="0"/>
+          <a:ext cx="0" cy="0"/>
+          <a:chOff x="0" y="0"/>
+          <a:chExt cx="0" cy="0"/>
+        </a:xfrm>
+      </p:grpSpPr>
+      <p:sp>
+        <p:nvSpPr>
+          <p:cNvPr id="2" name="Slide Image Placeholder 1"/>
+          <p:cNvSpPr>
+            <a:spLocks noGrp="1"/>
+          </p:cNvSpPr>
+          <p:nvPr>
+            <p:ph type="sldImg" idx="2"/>
+          </p:nvPr>
+        </p:nvSpPr>
+        <p:spPr/>
+      </p:sp>
+      <p:sp>
+        <p:nvSpPr>
+          <p:cNvPr id="3" name="Notes Placeholder 2"/>
+          <p:cNvSpPr>
+            <a:spLocks noGrp="1"/>
+          </p:cNvSpPr>
+          <p:nvPr>
+            <p:ph type="body" idx="3" sz="quarter"/>
+          </p:nvPr>
+        </p:nvSpPr>
+        <p:spPr/>
+        <p:txBody>
+          <a:bodyPr/>
+          <a:lstStyle/>
+          <a:p>
+            <a:r>
+              <a:t>【流匹配一句话】学习一个"速度场"，把随机噪声沿平滑路径"流动"成真实动作。类比：在动作空间铺设"风场"，训练学风往哪吹；生成时扔一粒沙子（噪声）进去，风把它吹到正确动作的位置。</a:t>
+            </a:r>
+          </a:p>
+          <a:p/>
+          <a:p>
+            <a:r>
+              <a:t>【公式拆解】min_θ E‖v_θ(a^τ,o,ℓ,τ) − (a−ε)‖²，a^τ = τ·a + (1−τ)·ε。a=真实动作块，ε=高斯噪声，τ∈[0,1] 流动时间，a^τ 是噪声与真实动作的直线插值点，(a−ε) 是直线方向向量（真实速度）。训练：采演示+噪声+时间→算插值点→网络预测速度→MSE 回归。网络学的是"路径上任何位置、任何时刻的正确前进方向"，且以图像和语言为条件。</a:t>
+            </a:r>
+          </a:p>
+          <a:p/>
+          <a:p>
+            <a:r>
+              <a:t>【怎么生成动作】推理 = 解 ODE（欧拉法）：从纯噪声 a⁰ 出发，迭代 10 次，每次算 v=v_θ(a^τ,o,ℓ,τ)，走一小步 a^{τ+Δτ}=a^τ+Δτ·v（Δτ=1/10），τ 到 1 时噪声已"流"成符合指令的 50 步连续动作块。</a:t>
+            </a:r>
+          </a:p>
+          <a:p/>
+          <a:p>
+            <a:r>
+              <a:t>【三大优势】1) 对比自回归：连续值无 256-bin 量化损失，50 步并行一次生成支撑 50Hz；2) 对比扩散：扩散走弯曲随机路径需几十上百步，流匹配走直线、训练更稳、10 步够；3) 天然多模态：不同初始噪声流向不同但都合理的动作，不会平均成错误动作。</a:t>
+            </a:r>
+          </a:p>
+          <a:p/>
+          <a:p>
+            <a:r>
+              <a:t>【备答】"10 步怎么定的"→精度与延迟的工程权衡；"与 Flow Matching 论文 OT 路径关系"→π0 用的就是线性插值（rectified flow）路径。</a:t>
+            </a:r>
+          </a:p>
+        </p:txBody>
+      </p:sp>
+      <p:sp>
+        <p:nvSpPr>
+          <p:cNvPr id="4" name="Slide Number Placeholder 3"/>
+          <p:cNvSpPr>
+            <a:spLocks noGrp="1"/>
+          </p:cNvSpPr>
+          <p:nvPr>
+            <p:ph type="sldNum" idx="5" sz="quarter"/>
+          </p:nvPr>
+        </p:nvSpPr>
+        <p:spPr/>
+      </p:sp>
+    </p:spTree>
+  </p:cSld>
+  <p:clrMapOvr>
+    <a:masterClrMapping/>
+  </p:clrMapOvr>
+</p:notes>
+</file>
+
+<file path=ppt/notesSlides/notesSlide5.xml><?xml version="1.0" encoding="utf-8"?>
+<p:notes xmlns:a="http://schemas.openxmlformats.org/drawingml/2006/main" xmlns:p="http://schemas.openxmlformats.org/presentationml/2006/main" xmlns:r="http://schemas.openxmlformats.org/officeDocument/2006/relationships">
+  <p:cSld>
+    <p:spTree>
+      <p:nvGrpSpPr>
+        <p:cNvPr id="1" name=""/>
+        <p:cNvGrpSpPr/>
+        <p:nvPr/>
+      </p:nvGrpSpPr>
+      <p:grpSpPr>
+        <a:xfrm>
+          <a:off x="0" y="0"/>
+          <a:ext cx="0" cy="0"/>
+          <a:chOff x="0" y="0"/>
+          <a:chExt cx="0" cy="0"/>
+        </a:xfrm>
+      </p:grpSpPr>
+      <p:sp>
+        <p:nvSpPr>
+          <p:cNvPr id="2" name="Slide Image Placeholder 1"/>
+          <p:cNvSpPr>
+            <a:spLocks noGrp="1"/>
+          </p:cNvSpPr>
+          <p:nvPr>
+            <p:ph type="sldImg" idx="2"/>
+          </p:nvPr>
+        </p:nvSpPr>
+        <p:spPr/>
+      </p:sp>
+      <p:sp>
+        <p:nvSpPr>
+          <p:cNvPr id="3" name="Notes Placeholder 2"/>
+          <p:cNvSpPr>
+            <a:spLocks noGrp="1"/>
+          </p:cNvSpPr>
+          <p:nvPr>
+            <p:ph type="body" idx="3" sz="quarter"/>
+          </p:nvPr>
+        </p:nvSpPr>
+        <p:spPr/>
+        <p:txBody>
+          <a:bodyPr/>
+          <a:lstStyle/>
+          <a:p>
+            <a:r>
+              <a:t>【讲稿框架】NVIDIA 打法不同：不只做模型，做整个生态。三个记忆点：双系统、数据金字塔、全栈生态。</a:t>
+            </a:r>
+          </a:p>
+          <a:p/>
+          <a:p>
+            <a:r>
+              <a:t>【双系统】借 Kahneman《思考，快与慢》：System 2（Eagle-2 VLM，~10Hz）慢思考——场景理解、指令解析、任务推理，"想清楚要做什么"；System 1（Diffusion Transformer 动作头，~120Hz）快执行——流匹配去噪生成连续动作块，"下意识执行"。为什么拆开：大模型推理慢，人形机器人平衡与操作需要高频控制——慢脑规划、快脑执行。</a:t>
+            </a:r>
+          </a:p>
+          <a:p/>
+          <a:p>
+            <a:r>
+              <a:t>【数据金字塔】解决真机数据太贵：塔基=海量网络视频/人类第一视角视频（无动作标签，用潜在动作模型/逆动力学打"伪动作"标签，学世界知识与操作先验）；塔身=仿真合成（Isaac Lab / GR00T-Dreams 世界模型）；塔尖=真实遥操作数据（最少最贵，锚定真实物理）。便宜数据学通识、贵数据对齐现实。</a:t>
+            </a:r>
+          </a:p>
+          <a:p/>
+          <a:p>
+            <a:r>
+              <a:t>【成果与生态】N1 为 2B 开放权重；N1.5 改进 VLM 对齐+FLARE 目标，语言跟随率 46.6%→93.3%（翻倍，解决"听不懂话"）；跨具身靠具身特定投影层。生态：Isaac Lab 仿真、OSMO 训练编排、Jetson Thor 端侧、TensorRT 优化——全栈打通难以复制。</a:t>
+            </a:r>
+          </a:p>
+          <a:p/>
+          <a:p>
+            <a:r>
+              <a:t>【备答】与 π0 本质区别→动作生成机制类似（流匹配），GR00T 显式解耦两系统运行频率、面向人形+数据金字塔+生态；伪动作怎么打→逆动力学从相邻帧反推动作，或无监督潜在动作模型。</a:t>
+            </a:r>
+          </a:p>
+        </p:txBody>
+      </p:sp>
+      <p:sp>
+        <p:nvSpPr>
+          <p:cNvPr id="4" name="Slide Number Placeholder 3"/>
+          <p:cNvSpPr>
+            <a:spLocks noGrp="1"/>
+          </p:cNvSpPr>
+          <p:nvPr>
+            <p:ph type="sldNum" idx="5" sz="quarter"/>
+          </p:nvPr>
+        </p:nvSpPr>
+        <p:spPr/>
+      </p:sp>
+    </p:spTree>
+  </p:cSld>
+  <p:clrMapOvr>
+    <a:masterClrMapping/>
+  </p:clrMapOvr>
+</p:notes>
+</file>
+
+<file path=ppt/notesSlides/notesSlide6.xml><?xml version="1.0" encoding="utf-8"?>
+<p:notes xmlns:a="http://schemas.openxmlformats.org/drawingml/2006/main" xmlns:p="http://schemas.openxmlformats.org/presentationml/2006/main" xmlns:r="http://schemas.openxmlformats.org/officeDocument/2006/relationships">
+  <p:cSld>
+    <p:spTree>
+      <p:nvGrpSpPr>
+        <p:cNvPr id="1" name=""/>
+        <p:cNvGrpSpPr/>
+        <p:nvPr/>
+      </p:nvGrpSpPr>
+      <p:grpSpPr>
+        <a:xfrm>
+          <a:off x="0" y="0"/>
+          <a:ext cx="0" cy="0"/>
+          <a:chOff x="0" y="0"/>
+          <a:chExt cx="0" cy="0"/>
+        </a:xfrm>
+      </p:grpSpPr>
+      <p:sp>
+        <p:nvSpPr>
+          <p:cNvPr id="2" name="Slide Image Placeholder 1"/>
+          <p:cNvSpPr>
+            <a:spLocks noGrp="1"/>
+          </p:cNvSpPr>
+          <p:nvPr>
+            <p:ph type="sldImg" idx="2"/>
+          </p:nvPr>
+        </p:nvSpPr>
+        <p:spPr/>
+      </p:sp>
+      <p:sp>
+        <p:nvSpPr>
+          <p:cNvPr id="3" name="Notes Placeholder 2"/>
+          <p:cNvSpPr>
+            <a:spLocks noGrp="1"/>
+          </p:cNvSpPr>
+          <p:nvPr>
+            <p:ph type="body" idx="3" sz="quarter"/>
+          </p:nvPr>
+        </p:nvSpPr>
+        <p:spPr/>
+        <p:txBody>
+          <a:bodyPr/>
+          <a:lstStyle/>
+          <a:p>
+            <a:r>
+              <a:t>【π0.7 与世界模型辨析】π0.7 本质仍是直接的视觉-语言-动作策略模型（direct policy），没有引入世界模型组件；业界评论恰认为它"挑战了世界模型范式"——证明直接图文→动作策略也能涌现推理与技能迁移。真正的世界模型在 GR00T 线：GR00T-Dreams 世界模型 / Cosmos 系列，用于生成仿真轨迹数据（数据金字塔塔身）。π 系列的"自我改进"是 π*0.6 的 RECAP 强化学习，也不是世界模型。</a:t>
+            </a:r>
+          </a:p>
+          <a:p/>
+          <a:p>
+            <a:r>
+              <a:t>【Qwen3-VL 是什么】三层关系：1) Qwen3-VL = 阿里通义千问团队开源的第三代视觉-语言模型家族（Qwen3 版本号 + VL=Vision-Language），当前最强开源 VLM 系列之一；2) Cosmos-Reason2-2B = NVIDIA 以 Qwen3-VL（2B 规模）为骨干架构、用物理世界/具身推理数据继续训练的"物理 AI 推理模型"，强化空间推理、时序理解、思维链，支持任意宽高比图像输入（保留边缘视野，对机器人安全重要）；3) GR00T N1.7 用它替换 N1/N1.5 的 Eagle-2 作为 System 2 慢思考骨干，输出语义嵌入喂给 System 1 的 DiT 动作头。</a:t>
+            </a:r>
+          </a:p>
+          <a:p/>
+          <a:p>
+            <a:r>
+              <a:t>【演讲点睛】这体现 VLA 领域"复用最强开源 VLM 做骨干"的普遍做法：π0 用 Google 的 PaliGemma，GR00T 用阿里的 Qwen3-VL——站在开源巨人肩膀上。</a:t>
+            </a:r>
+          </a:p>
+        </p:txBody>
+      </p:sp>
+      <p:sp>
+        <p:nvSpPr>
+          <p:cNvPr id="4" name="Slide Number Placeholder 3"/>
+          <p:cNvSpPr>
+            <a:spLocks noGrp="1"/>
+          </p:cNvSpPr>
+          <p:nvPr>
+            <p:ph type="sldNum" idx="5" sz="quarter"/>
+          </p:nvPr>
+        </p:nvSpPr>
+        <p:spPr/>
+      </p:sp>
+    </p:spTree>
+  </p:cSld>
+  <p:clrMapOvr>
+    <a:masterClrMapping/>
+  </p:clrMapOvr>
+</p:notes>
+</file>
+
+<file path=ppt/notesSlides/notesSlide7.xml><?xml version="1.0" encoding="utf-8"?>
+<p:notes xmlns:a="http://schemas.openxmlformats.org/drawingml/2006/main" xmlns:p="http://schemas.openxmlformats.org/presentationml/2006/main" xmlns:r="http://schemas.openxmlformats.org/officeDocument/2006/relationships">
+  <p:cSld>
+    <p:spTree>
+      <p:nvGrpSpPr>
+        <p:cNvPr id="1" name=""/>
+        <p:cNvGrpSpPr/>
+        <p:nvPr/>
+      </p:nvGrpSpPr>
+      <p:grpSpPr>
+        <a:xfrm>
+          <a:off x="0" y="0"/>
+          <a:ext cx="0" cy="0"/>
+          <a:chOff x="0" y="0"/>
+          <a:chExt cx="0" cy="0"/>
+        </a:xfrm>
+      </p:grpSpPr>
+      <p:sp>
+        <p:nvSpPr>
+          <p:cNvPr id="2" name="Slide Image Placeholder 1"/>
+          <p:cNvSpPr>
+            <a:spLocks noGrp="1"/>
+          </p:cNvSpPr>
+          <p:nvPr>
+            <p:ph type="sldImg" idx="2"/>
+          </p:nvPr>
+        </p:nvSpPr>
+        <p:spPr/>
+      </p:sp>
+      <p:sp>
+        <p:nvSpPr>
+          <p:cNvPr id="3" name="Notes Placeholder 2"/>
+          <p:cNvSpPr>
+            <a:spLocks noGrp="1"/>
+          </p:cNvSpPr>
+          <p:nvPr>
+            <p:ph type="body" idx="3" sz="quarter"/>
+          </p:nvPr>
+        </p:nvSpPr>
+        <p:spPr/>
+        <p:txBody>
+          <a:bodyPr/>
+          <a:lstStyle/>
+          <a:p>
+            <a:r>
+              <a:t>【⑦ 性能测试的三层漏斗】离线指标（验证集算动作 MSE/token 准确率，不动机器人，成本极低但可信度低）→ 仿真基准（LIBERO/SimplerEnv 跑任务统计成功率，成本中等）→ 实机 A/B（真实机器人对比，成本极高但最终裁决）。分层原因：离线指标好 ≠ 实机表现好，而实机太贵太慢，先便宜筛选再实机验证。</a:t>
+            </a:r>
+          </a:p>
+          <a:p/>
+          <a:p>
+            <a:r>
+              <a:t>【实机 A/B 是什么】借自互联网产品的对照实验：模型 A（旧版）与模型 B（新版）在同一台真机、同样任务集下各跑 N 次试验，通常交替/随机排序以消除环境漂移（光照、物体磨损、发热）。对比成功率、完成时间/吞吐量、失败模式；理想情况下现场打分者盲评（不知道跑的是 A 还是 B）；因试验次数少要做统计显著性判断。只有实机 A/B 赢了，新模型才替换上线。失败案例回流 ①补采/④增强 形成数据飞轮。</a:t>
+            </a:r>
+          </a:p>
+          <a:p/>
+          <a:p>
+            <a:r>
+              <a:t>【LIBERO】基于 MuJoCo/robosuite 的桌面操作仿真基准（Franka 单臂+语言任务），130 个任务分四套件考察不同泛化：Spatial（空间布局）、Object（物体）、Goal（任务目标）、Long（长时程）。学术界对比 VLA 的"标准考卷"，OpenVLA/π0 都报告 LIBERO 成功率。</a:t>
+            </a:r>
+          </a:p>
+          <a:p/>
+          <a:p>
+            <a:r>
+              <a:t>【SimplerEnv】解决"为真机训练的模型怎么在仿真评测"：在仿真中高保真复刻 Google Robot、WidowX/BridgeData 真实评测场景，对齐视觉外观与控制动力学，使仿真成功率与真机高度相关——"真机评测的廉价代理"，无需 Google 的机器人也能可复现对比 RT 系/Octo/OpenVLA。</a:t>
+            </a:r>
+          </a:p>
+        </p:txBody>
+      </p:sp>
+      <p:sp>
+        <p:nvSpPr>
+          <p:cNvPr id="4" name="Slide Number Placeholder 3"/>
+          <p:cNvSpPr>
+            <a:spLocks noGrp="1"/>
+          </p:cNvSpPr>
+          <p:nvPr>
+            <p:ph type="sldNum" idx="5" sz="quarter"/>
+          </p:nvPr>
+        </p:nvSpPr>
+        <p:spPr/>
+      </p:sp>
+    </p:spTree>
+  </p:cSld>
+  <p:clrMapOvr>
+    <a:masterClrMapping/>
+  </p:clrMapOvr>
+</p:notes>
+</file>
+
+<file path=ppt/notesSlides/notesSlide8.xml><?xml version="1.0" encoding="utf-8"?>
+<p:notes xmlns:a="http://schemas.openxmlformats.org/drawingml/2006/main" xmlns:p="http://schemas.openxmlformats.org/presentationml/2006/main" xmlns:r="http://schemas.openxmlformats.org/officeDocument/2006/relationships">
+  <p:cSld>
+    <p:spTree>
+      <p:nvGrpSpPr>
+        <p:cNvPr id="1" name=""/>
+        <p:cNvGrpSpPr/>
+        <p:nvPr/>
+      </p:nvGrpSpPr>
+      <p:grpSpPr>
+        <a:xfrm>
+          <a:off x="0" y="0"/>
+          <a:ext cx="0" cy="0"/>
+          <a:chOff x="0" y="0"/>
+          <a:chExt cx="0" cy="0"/>
+        </a:xfrm>
+      </p:grpSpPr>
+      <p:sp>
+        <p:nvSpPr>
+          <p:cNvPr id="2" name="Slide Image Placeholder 1"/>
+          <p:cNvSpPr>
+            <a:spLocks noGrp="1"/>
+          </p:cNvSpPr>
+          <p:nvPr>
+            <p:ph type="sldImg" idx="2"/>
+          </p:nvPr>
+        </p:nvSpPr>
+        <p:spPr/>
+      </p:sp>
+      <p:sp>
+        <p:nvSpPr>
+          <p:cNvPr id="3" name="Notes Placeholder 2"/>
+          <p:cNvSpPr>
+            <a:spLocks noGrp="1"/>
+          </p:cNvSpPr>
+          <p:nvPr>
+            <p:ph type="body" idx="3" sz="quarter"/>
+          </p:nvPr>
+        </p:nvSpPr>
+        <p:spPr/>
+        <p:txBody>
+          <a:bodyPr/>
+          <a:lstStyle/>
+          <a:p>
+            <a:r>
+              <a:t>【三种损失 = 三种动作表示下的同一目标】损失函数是"模型输出与正确答案差多远"的尺子，对应第 11 页三大流派：</a:t>
+            </a:r>
+          </a:p>
+          <a:p>
+            <a:r>
+              <a:t>1) 流匹配 MSE（π0/GR00T）：动作是连续向量，回归问题——预测速度与目标速度 (a−ε) 的平方差取平均，差得越多罚得越重；</a:t>
+            </a:r>
+          </a:p>
+          <a:p>
+            <a:r>
+              <a:t>2) Token 交叉熵（RT 系/π0-FAST）：动作离散化为 token，分类问题——从 256 个候选里选正确的，损失=−log P(正确 token)，与 GPT 训练完全相同（复用 LLM 训练栈的原因）；</a:t>
+            </a:r>
+          </a:p>
+          <a:p>
+            <a:r>
+              <a:t>3) ACT 的 L1 重建 + KL：CVAE 两项损失——L1=|预测−真实| 绝对值（对演示抖动等离群点不敏感，动作更锐利不过度平均）；KL 正则约束隐变量 z 的分布贴近 N(0,I)（防止编码器作弊塞信息、保证推理时可直接取 z=0/从先验采样）。</a:t>
+            </a:r>
+          </a:p>
+          <a:p/>
+          <a:p>
+            <a:r>
+              <a:t>【norm stats = 归一化统计量】对动作/状态做归一化用的数据集统计量（每维均值/标准差或分位数）。为什么需要：各维度量纲差异大（关节角 ±3.14 弧度 vs 位移 ±0.05 米 vs 夹爪 0/1），不归一化则大数值维度主导损失；流匹配还要求动作与 N(0,1) 噪声同尺度。训练前 (x−mean)/std，推理时用同一组统计量反归一化回物理量，随 checkpoint 一起保存。</a:t>
+            </a:r>
+          </a:p>
+          <a:p/>
+          <a:p>
+            <a:r>
+              <a:t>【为什么换平台必须重算】norm stats 绑定特定机器人的动作范围；沿用旧统计量会使归一化分布偏离模型预期，更危险的是反归一化输出错误物理量——可能生成超出安全范围的关节指令，轻则失败重则撞坏机器人。这是 VLA 微调最常见的坑。</a:t>
+            </a:r>
+          </a:p>
+        </p:txBody>
+      </p:sp>
+      <p:sp>
+        <p:nvSpPr>
+          <p:cNvPr id="4" name="Slide Number Placeholder 3"/>
+          <p:cNvSpPr>
+            <a:spLocks noGrp="1"/>
+          </p:cNvSpPr>
+          <p:nvPr>
+            <p:ph type="sldNum" idx="5" sz="quarter"/>
+          </p:nvPr>
+        </p:nvSpPr>
+        <p:spPr/>
+      </p:sp>
+    </p:spTree>
+  </p:cSld>
+  <p:clrMapOvr>
+    <a:masterClrMapping/>
+  </p:clrMapOvr>
+</p:notes>
 </file>
 
 <file path=ppt/slideLayouts/slideLayout1.xml><?xml version="1.0" encoding="utf-8"?>
@@ -29254,4 +30335,324 @@
   </a:objectDefaults>
   <a:extraClrSchemeLst/>
 </a:theme>
+</file>
+
+<file path=ppt/theme/theme2.xml><?xml version="1.0" encoding="utf-8"?>
+<a:theme xmlns:a="http://schemas.openxmlformats.org/drawingml/2006/main" name="Office Theme">
+  <a:themeElements>
+    <a:clrScheme name="Office">
+      <a:dk1>
+        <a:sysClr val="windowText" lastClr="000000"/>
+      </a:dk1>
+      <a:lt1>
+        <a:sysClr val="window" lastClr="FFFFFF"/>
+      </a:lt1>
+      <a:dk2>
+        <a:srgbClr val="1F497D"/>
+      </a:dk2>
+      <a:lt2>
+        <a:srgbClr val="EEECE1"/>
+      </a:lt2>
+      <a:accent1>
+        <a:srgbClr val="4F81BD"/>
+      </a:accent1>
+      <a:accent2>
+        <a:srgbClr val="C0504D"/>
+      </a:accent2>
+      <a:accent3>
+        <a:srgbClr val="9BBB59"/>
+      </a:accent3>
+      <a:accent4>
+        <a:srgbClr val="8064A2"/>
+      </a:accent4>
+      <a:accent5>
+        <a:srgbClr val="4BACC6"/>
+      </a:accent5>
+      <a:accent6>
+        <a:srgbClr val="F79646"/>
+      </a:accent6>
+      <a:hlink>
+        <a:srgbClr val="0000FF"/>
+      </a:hlink>
+      <a:folHlink>
+        <a:srgbClr val="800080"/>
+      </a:folHlink>
+    </a:clrScheme>
+    <a:fontScheme name="Office">
+      <a:majorFont>
+        <a:latin typeface="Calibri"/>
+        <a:ea typeface=""/>
+        <a:cs typeface=""/>
+        <a:font script="Jpan" typeface="ＭＳ Ｐゴシック"/>
+        <a:font script="Hang" typeface="맑은 고딕"/>
+        <a:font script="Hans" typeface="宋体"/>
+        <a:font script="Hant" typeface="新細明體"/>
+        <a:font script="Arab" typeface="Times New Roman"/>
+        <a:font script="Hebr" typeface="Times New Roman"/>
+        <a:font script="Thai" typeface="Angsana New"/>
+        <a:font script="Ethi" typeface="Nyala"/>
+        <a:font script="Beng" typeface="Vrinda"/>
+        <a:font script="Gujr" typeface="Shruti"/>
+        <a:font script="Khmr" typeface="MoolBoran"/>
+        <a:font script="Knda" typeface="Tunga"/>
+        <a:font script="Guru" typeface="Raavi"/>
+        <a:font script="Cans" typeface="Euphemia"/>
+        <a:font script="Cher" typeface="Plantagenet Cherokee"/>
+        <a:font script="Yiii" typeface="Microsoft Yi Baiti"/>
+        <a:font script="Tibt" typeface="Microsoft Himalaya"/>
+        <a:font script="Thaa" typeface="MV Boli"/>
+        <a:font script="Deva" typeface="Mangal"/>
+        <a:font script="Telu" typeface="Gautami"/>
+        <a:font script="Taml" typeface="Latha"/>
+        <a:font script="Syrc" typeface="Estrangelo Edessa"/>
+        <a:font script="Orya" typeface="Kalinga"/>
+        <a:font script="Mlym" typeface="Kartika"/>
+        <a:font script="Laoo" typeface="DokChampa"/>
+        <a:font script="Sinh" typeface="Iskoola Pota"/>
+        <a:font script="Mong" typeface="Mongolian Baiti"/>
+        <a:font script="Viet" typeface="Times New Roman"/>
+        <a:font script="Uigh" typeface="Microsoft Uighur"/>
+        <a:font script="Geor" typeface="Sylfaen"/>
+      </a:majorFont>
+      <a:minorFont>
+        <a:latin typeface="Calibri"/>
+        <a:ea typeface=""/>
+        <a:cs typeface=""/>
+        <a:font script="Jpan" typeface="ＭＳ Ｐゴシック"/>
+        <a:font script="Hang" typeface="맑은 고딕"/>
+        <a:font script="Hans" typeface="宋体"/>
+        <a:font script="Hant" typeface="新細明體"/>
+        <a:font script="Arab" typeface="Arial"/>
+        <a:font script="Hebr" typeface="Arial"/>
+        <a:font script="Thai" typeface="Cordia New"/>
+        <a:font script="Ethi" typeface="Nyala"/>
+        <a:font script="Beng" typeface="Vrinda"/>
+        <a:font script="Gujr" typeface="Shruti"/>
+        <a:font script="Khmr" typeface="DaunPenh"/>
+        <a:font script="Knda" typeface="Tunga"/>
+        <a:font script="Guru" typeface="Raavi"/>
+        <a:font script="Cans" typeface="Euphemia"/>
+        <a:font script="Cher" typeface="Plantagenet Cherokee"/>
+        <a:font script="Yiii" typeface="Microsoft Yi Baiti"/>
+        <a:font script="Tibt" typeface="Microsoft Himalaya"/>
+        <a:font script="Thaa" typeface="MV Boli"/>
+        <a:font script="Deva" typeface="Mangal"/>
+        <a:font script="Telu" typeface="Gautami"/>
+        <a:font script="Taml" typeface="Latha"/>
+        <a:font script="Syrc" typeface="Estrangelo Edessa"/>
+        <a:font script="Orya" typeface="Kalinga"/>
+        <a:font script="Mlym" typeface="Kartika"/>
+        <a:font script="Laoo" typeface="DokChampa"/>
+        <a:font script="Sinh" typeface="Iskoola Pota"/>
+        <a:font script="Mong" typeface="Mongolian Baiti"/>
+        <a:font script="Viet" typeface="Arial"/>
+        <a:font script="Uigh" typeface="Microsoft Uighur"/>
+        <a:font script="Geor" typeface="Sylfaen"/>
+      </a:minorFont>
+    </a:fontScheme>
+    <a:fmtScheme name="Office">
+      <a:fillStyleLst>
+        <a:solidFill>
+          <a:schemeClr val="phClr"/>
+        </a:solidFill>
+        <a:gradFill rotWithShape="1">
+          <a:gsLst>
+            <a:gs pos="0">
+              <a:schemeClr val="phClr">
+                <a:tint val="50000"/>
+                <a:satMod val="300000"/>
+              </a:schemeClr>
+            </a:gs>
+            <a:gs pos="35000">
+              <a:schemeClr val="phClr">
+                <a:tint val="37000"/>
+                <a:satMod val="300000"/>
+              </a:schemeClr>
+            </a:gs>
+            <a:gs pos="100000">
+              <a:schemeClr val="phClr">
+                <a:tint val="15000"/>
+                <a:satMod val="350000"/>
+              </a:schemeClr>
+            </a:gs>
+          </a:gsLst>
+          <a:lin ang="16200000" scaled="1"/>
+        </a:gradFill>
+        <a:gradFill rotWithShape="1">
+          <a:gsLst>
+            <a:gs pos="0">
+              <a:schemeClr val="phClr">
+                <a:tint val="100000"/>
+                <a:shade val="100000"/>
+                <a:satMod val="130000"/>
+              </a:schemeClr>
+            </a:gs>
+            <a:gs pos="100000">
+              <a:schemeClr val="phClr">
+                <a:tint val="50000"/>
+                <a:shade val="100000"/>
+                <a:satMod val="350000"/>
+              </a:schemeClr>
+            </a:gs>
+          </a:gsLst>
+          <a:lin ang="16200000" scaled="0"/>
+        </a:gradFill>
+      </a:fillStyleLst>
+      <a:lnStyleLst>
+        <a:ln w="9525" cap="flat" cmpd="sng" algn="ctr">
+          <a:solidFill>
+            <a:schemeClr val="phClr">
+              <a:shade val="95000"/>
+              <a:satMod val="105000"/>
+            </a:schemeClr>
+          </a:solidFill>
+          <a:prstDash val="solid"/>
+        </a:ln>
+        <a:ln w="25400" cap="flat" cmpd="sng" algn="ctr">
+          <a:solidFill>
+            <a:schemeClr val="phClr"/>
+          </a:solidFill>
+          <a:prstDash val="solid"/>
+        </a:ln>
+        <a:ln w="38100" cap="flat" cmpd="sng" algn="ctr">
+          <a:solidFill>
+            <a:schemeClr val="phClr"/>
+          </a:solidFill>
+          <a:prstDash val="solid"/>
+        </a:ln>
+      </a:lnStyleLst>
+      <a:effectStyleLst>
+        <a:effectStyle>
+          <a:effectLst>
+            <a:outerShdw blurRad="40000" dist="20000" dir="5400000" rotWithShape="0">
+              <a:srgbClr val="000000">
+                <a:alpha val="38000"/>
+              </a:srgbClr>
+            </a:outerShdw>
+          </a:effectLst>
+        </a:effectStyle>
+        <a:effectStyle>
+          <a:effectLst>
+            <a:outerShdw blurRad="40000" dist="23000" dir="5400000" rotWithShape="0">
+              <a:srgbClr val="000000">
+                <a:alpha val="35000"/>
+              </a:srgbClr>
+            </a:outerShdw>
+          </a:effectLst>
+        </a:effectStyle>
+        <a:effectStyle>
+          <a:effectLst>
+            <a:outerShdw blurRad="40000" dist="23000" dir="5400000" rotWithShape="0">
+              <a:srgbClr val="000000">
+                <a:alpha val="35000"/>
+              </a:srgbClr>
+            </a:outerShdw>
+          </a:effectLst>
+          <a:scene3d>
+            <a:camera prst="orthographicFront">
+              <a:rot lat="0" lon="0" rev="0"/>
+            </a:camera>
+            <a:lightRig rig="threePt" dir="t">
+              <a:rot lat="0" lon="0" rev="1200000"/>
+            </a:lightRig>
+          </a:scene3d>
+          <a:sp3d>
+            <a:bevelT w="63500" h="25400"/>
+          </a:sp3d>
+        </a:effectStyle>
+      </a:effectStyleLst>
+      <a:bgFillStyleLst>
+        <a:solidFill>
+          <a:schemeClr val="phClr"/>
+        </a:solidFill>
+        <a:gradFill rotWithShape="1">
+          <a:gsLst>
+            <a:gs pos="0">
+              <a:schemeClr val="phClr">
+                <a:tint val="40000"/>
+                <a:satMod val="350000"/>
+              </a:schemeClr>
+            </a:gs>
+            <a:gs pos="40000">
+              <a:schemeClr val="phClr">
+                <a:tint val="45000"/>
+                <a:shade val="99000"/>
+                <a:satMod val="350000"/>
+              </a:schemeClr>
+            </a:gs>
+            <a:gs pos="100000">
+              <a:schemeClr val="phClr">
+                <a:shade val="20000"/>
+                <a:satMod val="255000"/>
+              </a:schemeClr>
+            </a:gs>
+          </a:gsLst>
+          <a:path path="circle">
+            <a:fillToRect l="50000" t="-80000" r="50000" b="180000"/>
+          </a:path>
+        </a:gradFill>
+        <a:gradFill rotWithShape="1">
+          <a:gsLst>
+            <a:gs pos="0">
+              <a:schemeClr val="phClr">
+                <a:tint val="80000"/>
+                <a:satMod val="300000"/>
+              </a:schemeClr>
+            </a:gs>
+            <a:gs pos="100000">
+              <a:schemeClr val="phClr">
+                <a:shade val="30000"/>
+                <a:satMod val="200000"/>
+              </a:schemeClr>
+            </a:gs>
+          </a:gsLst>
+          <a:path path="circle">
+            <a:fillToRect l="50000" t="50000" r="50000" b="50000"/>
+          </a:path>
+        </a:gradFill>
+      </a:bgFillStyleLst>
+    </a:fmtScheme>
+  </a:themeElements>
+  <a:objectDefaults>
+    <a:spDef>
+      <a:spPr/>
+      <a:bodyPr/>
+      <a:lstStyle/>
+      <a:style>
+        <a:lnRef idx="1">
+          <a:schemeClr val="accent1"/>
+        </a:lnRef>
+        <a:fillRef idx="3">
+          <a:schemeClr val="accent1"/>
+        </a:fillRef>
+        <a:effectRef idx="2">
+          <a:schemeClr val="accent1"/>
+        </a:effectRef>
+        <a:fontRef idx="minor">
+          <a:schemeClr val="lt1"/>
+        </a:fontRef>
+      </a:style>
+    </a:spDef>
+    <a:lnDef>
+      <a:spPr/>
+      <a:bodyPr/>
+      <a:lstStyle/>
+      <a:style>
+        <a:lnRef idx="2">
+          <a:schemeClr val="accent1"/>
+        </a:lnRef>
+        <a:fillRef idx="0">
+          <a:schemeClr val="accent1"/>
+        </a:fillRef>
+        <a:effectRef idx="1">
+          <a:schemeClr val="accent1"/>
+        </a:effectRef>
+        <a:fontRef idx="minor">
+          <a:schemeClr val="tx1"/>
+        </a:fontRef>
+      </a:style>
+    </a:lnDef>
+  </a:objectDefaults>
+  <a:extraClrSchemeLst/>
+</a:theme>
 </file>
</xml_diff>